<commit_message>
final: actualizar presentación y mantener guion privado
</commit_message>
<xml_diff>
--- a/fase-4/sumativa-3/presentacion/presentacion_sumativa_3.pptx
+++ b/fase-4/sumativa-3/presentacion/presentacion_sumativa_3.pptx
@@ -2,22 +2,22 @@
 <file path=ppt/presentation.xml><?xml version="1.0" encoding="utf-8"?>
 <p:presentation xmlns:p="http://schemas.openxmlformats.org/presentationml/2006/main">
   <p:sldMasterIdLst>
-    <p:sldMasterId xmlns:r="http://schemas.openxmlformats.org/officeDocument/2006/relationships" id="2147483648" r:id="R16e346e859584470"/>
+    <p:sldMasterId xmlns:r="http://schemas.openxmlformats.org/officeDocument/2006/relationships" id="2147483648" r:id="Rf987354a9c5b43ea"/>
   </p:sldMasterIdLst>
   <p:notesMasterIdLst>
-    <p:notesMasterId xmlns:r="http://schemas.openxmlformats.org/officeDocument/2006/relationships" r:id="R739b41bac70a47f9"/>
+    <p:notesMasterId xmlns:r="http://schemas.openxmlformats.org/officeDocument/2006/relationships" r:id="R2816d8717eb140ea"/>
   </p:notesMasterIdLst>
   <p:sldIdLst>
-    <p:sldId xmlns:r="http://schemas.openxmlformats.org/officeDocument/2006/relationships" id="256" r:id="Rdb879ac1979e4d07"/>
-    <p:sldId xmlns:r="http://schemas.openxmlformats.org/officeDocument/2006/relationships" id="257" r:id="Ref10fb35f78d4bf9"/>
-    <p:sldId xmlns:r="http://schemas.openxmlformats.org/officeDocument/2006/relationships" id="258" r:id="R37402ec84c8e4c4a"/>
-    <p:sldId xmlns:r="http://schemas.openxmlformats.org/officeDocument/2006/relationships" id="259" r:id="Rd896ebbe3dbf41d9"/>
-    <p:sldId xmlns:r="http://schemas.openxmlformats.org/officeDocument/2006/relationships" id="260" r:id="R3b1a121fd754451b"/>
-    <p:sldId xmlns:r="http://schemas.openxmlformats.org/officeDocument/2006/relationships" id="261" r:id="R61fba533b49341f6"/>
-    <p:sldId xmlns:r="http://schemas.openxmlformats.org/officeDocument/2006/relationships" id="262" r:id="Ra53222138abd41c4"/>
-    <p:sldId xmlns:r="http://schemas.openxmlformats.org/officeDocument/2006/relationships" id="263" r:id="Re64950c4262645e2"/>
-    <p:sldId xmlns:r="http://schemas.openxmlformats.org/officeDocument/2006/relationships" id="264" r:id="R4f07915720f742b5"/>
-    <p:sldId xmlns:r="http://schemas.openxmlformats.org/officeDocument/2006/relationships" id="265" r:id="R7c3763a3e8554a3a"/>
+    <p:sldId xmlns:r="http://schemas.openxmlformats.org/officeDocument/2006/relationships" id="256" r:id="Rcc28edd0dae84a26"/>
+    <p:sldId xmlns:r="http://schemas.openxmlformats.org/officeDocument/2006/relationships" id="257" r:id="R4e8bd753501840e0"/>
+    <p:sldId xmlns:r="http://schemas.openxmlformats.org/officeDocument/2006/relationships" id="258" r:id="Rf7713a7bee024feb"/>
+    <p:sldId xmlns:r="http://schemas.openxmlformats.org/officeDocument/2006/relationships" id="259" r:id="Rc0cb5b15fbc8489f"/>
+    <p:sldId xmlns:r="http://schemas.openxmlformats.org/officeDocument/2006/relationships" id="260" r:id="Rf6f213b0075c4770"/>
+    <p:sldId xmlns:r="http://schemas.openxmlformats.org/officeDocument/2006/relationships" id="261" r:id="R377d20b7d2664fc7"/>
+    <p:sldId xmlns:r="http://schemas.openxmlformats.org/officeDocument/2006/relationships" id="262" r:id="R256377728c8140f6"/>
+    <p:sldId xmlns:r="http://schemas.openxmlformats.org/officeDocument/2006/relationships" id="263" r:id="R4ecb4ac1fb0548ac"/>
+    <p:sldId xmlns:r="http://schemas.openxmlformats.org/officeDocument/2006/relationships" id="264" r:id="Rcbef9261b9e847e8"/>
+    <p:sldId xmlns:r="http://schemas.openxmlformats.org/officeDocument/2006/relationships" id="265" r:id="R36015068e6ac4681"/>
   </p:sldIdLst>
   <p:sldSz cx="12192000" cy="6858000"/>
   <p:notesSz cx="6858000" cy="9144000"/>
@@ -451,7 +451,27 @@
           <a:lstStyle xmlns:a="http://schemas.openxmlformats.org/drawingml/2006/main"/>
           <a:p xmlns:a="http://schemas.openxmlformats.org/drawingml/2006/main">
             <a:r>
-              <a:t>Buenos días. En esta presentación resumiré el proyecto desarrollado con los datos de Framingham. El objetivo fue estudiar el riesgo de enfermedad coronaria a diez años e integrar, en una sola línea de trabajo, la exploración de la Sumativa 1, la validación de la Sumativa 2 y el modelamiento predictivo de la Sumativa 3. La exposición dura aproximadamente diez minutos.</a:t>
+              <a:t>[LAS INDICACIONES ENTRE CORCHETES NO SE LEEN EN VOZ ALTA.]</a:t>
+            </a:r>
+          </a:p>
+          <a:p xmlns:a="http://schemas.openxmlformats.org/drawingml/2006/main">
+            <a:r>
+              <a:t/>
+            </a:r>
+          </a:p>
+          <a:p xmlns:a="http://schemas.openxmlformats.org/drawingml/2006/main">
+            <a:r>
+              <a:t>[MIRAR A CÁMARA. No usar el puntero todavía.]</a:t>
+            </a:r>
+          </a:p>
+          <a:p xmlns:a="http://schemas.openxmlformats.org/drawingml/2006/main">
+            <a:r>
+              <a:t/>
+            </a:r>
+          </a:p>
+          <a:p xmlns:a="http://schemas.openxmlformats.org/drawingml/2006/main">
+            <a:r>
+              <a:t>Buenos días. En esta presentación resumiré el proyecto desarrollado con los datos de Framingham. El objetivo fue estudiar el riesgo de enfermedad coronaria a diez años y conectar lo realizado en tres etapas: la exploración de la Sumativa 1, la validación de la Sumativa 2 y el modelamiento predictivo de la Sumativa 3.</a:t>
             </a:r>
           </a:p>
           <a:p xmlns:a="http://schemas.openxmlformats.org/drawingml/2006/main">
@@ -531,7 +551,27 @@
           <a:lstStyle xmlns:a="http://schemas.openxmlformats.org/drawingml/2006/main"/>
           <a:p xmlns:a="http://schemas.openxmlformats.org/drawingml/2006/main">
             <a:r>
-              <a:t>En conclusión, M3 ofreció el mejor equilibrio entre desempeño y simplicidad. El modelo detectó una parte relevante de los casos, pero su discriminación fue moderada y la baja precisión produjo numerosos falsos positivos. Las asociaciones fueron estables dentro del dataset, aunque eso no demuestra causalidad ni garantiza el mismo funcionamiento en otra población. Antes de aplicarlo habría que validarlo en otra población, calibrar los puntajes y elegir el umbral según el costo de los errores. También conviene anidar todo el preprocesamiento, comparar imputación múltiple y modelar la edad de forma flexible. El principal valor del trabajo es metodológico: integra exploración, validación y predicción de manera reproducible y reconoce con claridad sus límites. Muchas gracias.</a:t>
+              <a:t>[PUNTERO: señalar primero las conclusiones de la izquierda y luego los próximos pasos de la derecha. Terminar señalando la franja azul inferior.]</a:t>
+            </a:r>
+          </a:p>
+          <a:p xmlns:a="http://schemas.openxmlformats.org/drawingml/2006/main">
+            <a:r>
+              <a:t/>
+            </a:r>
+          </a:p>
+          <a:p xmlns:a="http://schemas.openxmlformats.org/drawingml/2006/main">
+            <a:r>
+              <a:t>En conclusión, M3 ofreció el mejor equilibrio entre desempeño y simplicidad. El modelo detectó una parte relevante de los casos, pero su discriminación fue moderada y la baja precisión produjo numerosos falsos positivos. Las asociaciones fueron estables dentro del dataset, aunque eso no demuestra causalidad ni garantiza el mismo funcionamiento en otra población. Antes de aplicarlo habría que validarlo en otra población, calibrar los puntajes y elegir el umbral según el costo de los errores. También conviene anidar todo el preprocesamiento, comparar imputación múltiple y modelar la edad de forma flexible. El principal valor del trabajo es metodológico: integra exploración, validación y predicción de manera reproducible y reconoce con claridad sus límites.</a:t>
+            </a:r>
+          </a:p>
+          <a:p xmlns:a="http://schemas.openxmlformats.org/drawingml/2006/main">
+            <a:r>
+              <a:t/>
+            </a:r>
+          </a:p>
+          <a:p xmlns:a="http://schemas.openxmlformats.org/drawingml/2006/main">
+            <a:r>
+              <a:t>[MIRAR A CÁMARA para decir: Muchas gracias.]</a:t>
             </a:r>
           </a:p>
           <a:p xmlns:a="http://schemas.openxmlformats.org/drawingml/2006/main">
@@ -609,6 +649,36 @@
         <p:txBody>
           <a:bodyPr xmlns:a="http://schemas.openxmlformats.org/drawingml/2006/main"/>
           <a:lstStyle xmlns:a="http://schemas.openxmlformats.org/drawingml/2006/main"/>
+          <a:p xmlns:a="http://schemas.openxmlformats.org/drawingml/2006/main">
+            <a:r>
+              <a:t>[MIRAR A CÁMARA para introducir la diapositiva. Luego señalar con el PUNTERO la pregunta del lado izquierdo.]</a:t>
+            </a:r>
+          </a:p>
+          <a:p xmlns:a="http://schemas.openxmlformats.org/drawingml/2006/main">
+            <a:r>
+              <a:t/>
+            </a:r>
+          </a:p>
+          <a:p xmlns:a="http://schemas.openxmlformats.org/drawingml/2006/main">
+            <a:r>
+              <a:t>La pregunta que guio el proyecto fue: ¿Qué características se asocian con la enfermedad coronaria a diez años y con qué capacidad un modelo distingue perfiles con y sin evento?</a:t>
+            </a:r>
+          </a:p>
+          <a:p xmlns:a="http://schemas.openxmlformats.org/drawingml/2006/main">
+            <a:r>
+              <a:t/>
+            </a:r>
+          </a:p>
+          <a:p xmlns:a="http://schemas.openxmlformats.org/drawingml/2006/main">
+            <a:r>
+              <a:t>[PUNTERO: señalar, uno por uno, 4.238 personas, 16 variables, 15,20 por ciento y 10 años.]</a:t>
+            </a:r>
+          </a:p>
+          <a:p xmlns:a="http://schemas.openxmlformats.org/drawingml/2006/main">
+            <a:r>
+              <a:t/>
+            </a:r>
+          </a:p>
           <a:p xmlns:a="http://schemas.openxmlformats.org/drawingml/2006/main">
             <a:r>
               <a:t>Trabajamos con 4.238 personas y 16 variables demográficas, conductuales y clínicas. La variable objetivo fue TenYearCHD: CHD significa enfermedad coronaria. Esta variable indica si la persona desarrolló el evento durante diez años. El 15,20 por ciento presentó el evento. Esto genera desbalance, porque el grupo positivo es mucho menor. Nuestro objetivo no fue afirmar que una variable causa la enfermedad, sino estudiar asociaciones y evaluar qué tan bien el modelo distingue personas con y sin evento.</a:t>
@@ -691,7 +761,27 @@
           <a:lstStyle xmlns:a="http://schemas.openxmlformats.org/drawingml/2006/main"/>
           <a:p xmlns:a="http://schemas.openxmlformats.org/drawingml/2006/main">
             <a:r>
-              <a:t>El proyecto avanzó en tres etapas conectadas. En S1 diagnosticamos la calidad de los datos; allí destacaron, entre otras, la edad y la presión sistólica. En S2 evaluamos la estabilidad mediante bootstrap, permutación y sensibilidad frente a valores extremos. De manera complementaria, Monte Carlo mostró la variación de tasas en cohortes hipotéticas generadas con parámetros fijos; no fue una validación externa ni una comprobación de las asociaciones. En S3, esas fases orientaron la preparación y la comparación de candidatos; M3 seleccionó finalmente las variables mediante BIC.</a:t>
+              <a:t>[PUNTERO: recorrer las tres columnas de izquierda a derecha: S1, S2 y S3.]</a:t>
+            </a:r>
+          </a:p>
+          <a:p xmlns:a="http://schemas.openxmlformats.org/drawingml/2006/main">
+            <a:r>
+              <a:t/>
+            </a:r>
+          </a:p>
+          <a:p xmlns:a="http://schemas.openxmlformats.org/drawingml/2006/main">
+            <a:r>
+              <a:t>El proyecto avanzó en tres etapas conectadas. En S1 diagnosticamos la calidad de los datos; allí destacaron, entre otras, la edad y la presión sistólica. En S2 evaluamos la estabilidad mediante bootstrap, permutación y sensibilidad frente a valores extremos. Monte Carlo complementó el análisis al simular tasas bajo parámetros fijos; no fue una validación externa. En S3, esas fases orientaron la preparación y la comparación de candidatos; M3 seleccionó finalmente las variables mediante BIC.</a:t>
+            </a:r>
+          </a:p>
+          <a:p xmlns:a="http://schemas.openxmlformats.org/drawingml/2006/main">
+            <a:r>
+              <a:t/>
+            </a:r>
+          </a:p>
+          <a:p xmlns:a="http://schemas.openxmlformats.org/drawingml/2006/main">
+            <a:r>
+              <a:t>[MIRAR A CÁMARA al explicar que cada fase utilizó la evidencia de la anterior.]</a:t>
             </a:r>
           </a:p>
           <a:p xmlns:a="http://schemas.openxmlformats.org/drawingml/2006/main">
@@ -769,6 +859,16 @@
         <p:txBody>
           <a:bodyPr xmlns:a="http://schemas.openxmlformats.org/drawingml/2006/main"/>
           <a:lstStyle xmlns:a="http://schemas.openxmlformats.org/drawingml/2006/main"/>
+          <a:p xmlns:a="http://schemas.openxmlformats.org/drawingml/2006/main">
+            <a:r>
+              <a:t>[PUNTERO: señalar primero 9,16 por ciento; después las tres estrategias; finalmente las curvas azul y roja de glucosa.]</a:t>
+            </a:r>
+          </a:p>
+          <a:p xmlns:a="http://schemas.openxmlformats.org/drawingml/2006/main">
+            <a:r>
+              <a:t/>
+            </a:r>
+          </a:p>
           <a:p xmlns:a="http://schemas.openxmlformats.org/drawingml/2006/main">
             <a:r>
               <a:t>Los datos faltantes podían reducir la muestra y cambiar su composición. Glucosa fue la variable más afectada, con 9,16 por ciento de valores ausentes. Comparamos tres estrategias: eliminar registros incompletos, aplicar imputación simple y estimar los valores mediante regresiones lineales múltiples. Elegimos la imputación por regresión porque conserva todas las observaciones y utiliza varias variables predictoras. Sin embargo, la figura muestra que la imputación determinista concentra los valores y que varias regresiones tuvieron capacidad explicativa limitada. Por eso la decisión se considera razonable, pero no perfecta.</a:t>
@@ -851,6 +951,16 @@
           <a:lstStyle xmlns:a="http://schemas.openxmlformats.org/drawingml/2006/main"/>
           <a:p xmlns:a="http://schemas.openxmlformats.org/drawingml/2006/main">
             <a:r>
+              <a:t>[PUNTERO: recorrer las filas M1, M2 y M3. Detenerse en la fila verde de M3 y luego señalar cinco variables.]</a:t>
+            </a:r>
+          </a:p>
+          <a:p xmlns:a="http://schemas.openxmlformats.org/drawingml/2006/main">
+            <a:r>
+              <a:t/>
+            </a:r>
+          </a:p>
+          <a:p xmlns:a="http://schemas.openxmlformats.org/drawingml/2006/main">
+            <a:r>
               <a:t>Construimos tres modelos. M1 combinó seis variables destacadas en S1 y S2 e incorporó en S3 un término cuadrático para edad. M2 aplicó selección stepwise. M3 eliminó variables hacia atrás minimizando el BIC, un criterio que equilibra ajuste y complejidad. El AUC es el área bajo la curva ROC y resume la capacidad de discriminación. M2 obtuvo el mayor AUC promedio en validación cruzada, pero M3 quedó prácticamente empatado con tres variables menos. La regla de un error estándar favoreció M3 por parsimonia. El modelo final incluyó edad, cigarrillos diarios, presión sistólica, glucosa y sexo. El conjunto de prueba no participó en esta selección.</a:t>
             </a:r>
           </a:p>
@@ -929,6 +1039,16 @@
         <p:txBody>
           <a:bodyPr xmlns:a="http://schemas.openxmlformats.org/drawingml/2006/main"/>
           <a:lstStyle xmlns:a="http://schemas.openxmlformats.org/drawingml/2006/main"/>
+          <a:p xmlns:a="http://schemas.openxmlformats.org/drawingml/2006/main">
+            <a:r>
+              <a:t>[PUNTERO: señalar la curva ROC y explicar que la diagonal representa el azar. Después señalar la matriz: 116 verdaderos positivos, 77 falsos negativos y 352 falsos positivos. Terminar recorriendo las cuatro métricas inferiores.]</a:t>
+            </a:r>
+          </a:p>
+          <a:p xmlns:a="http://schemas.openxmlformats.org/drawingml/2006/main">
+            <a:r>
+              <a:t/>
+            </a:r>
+          </a:p>
           <a:p xmlns:a="http://schemas.openxmlformats.org/drawingml/2006/main">
             <a:r>
               <a:t>En el conjunto de prueba, M3 obtuvo un AUC de 0,7026, que corresponde a una discriminación moderada. La sensibilidad fue 0,6010, por lo que detectó aproximadamente seis de cada diez casos con enfermedad coronaria. La precisión fue 0,2479: cerca de una de cada cuatro alertas correspondió realmente a un caso positivo. F1 resume el equilibrio entre sensibilidad y precisión. En la matriz de confusión observamos 116 verdaderos positivos, 77 falsos negativos y 352 falsos positivos. La ponderación buscó aumentar la detección; con el umbral 0,5 se observaron esos 352 falsos positivos. Por eso estos puntajes no deben interpretarse como probabilidades clínicas calibradas.</a:t>
@@ -1011,6 +1131,16 @@
           <a:lstStyle xmlns:a="http://schemas.openxmlformats.org/drawingml/2006/main"/>
           <a:p xmlns:a="http://schemas.openxmlformats.org/drawingml/2006/main">
             <a:r>
+              <a:t>[PUNTERO: señalar 1.000 remuestras y 95 por ciento. En el gráfico, señalar la línea vertical de OR igual a 1 y luego los cinco intervalos ubicados a su derecha.]</a:t>
+            </a:r>
+          </a:p>
+          <a:p xmlns:a="http://schemas.openxmlformats.org/drawingml/2006/main">
+            <a:r>
+              <a:t/>
+            </a:r>
+          </a:p>
+          <a:p xmlns:a="http://schemas.openxmlformats.org/drawingml/2006/main">
+            <a:r>
               <a:t>Después evaluamos la estabilidad del modelo con bootstrap. Generamos mil remuestras con reemplazo del conjunto de entrenamiento y reajustamos el modelo en cada una. Los cinco intervalos de confianza, o IC, percentil al 95 por ciento de los odds ratios, también llamados razones de momios, quedaron por encima de uno y fueron próximos a los intervalos tradicionales de Wald. Esto indica que las asociaciones positivas fueron internamente estables. Sin embargo, el bootstrap usa el mismo origen de datos y mantiene fija la imputación y la selección. Por tanto, no demuestra causalidad ni reemplaza una validación externa.</a:t>
             </a:r>
           </a:p>
@@ -1089,6 +1219,16 @@
         <p:txBody>
           <a:bodyPr xmlns:a="http://schemas.openxmlformats.org/drawingml/2006/main"/>
           <a:lstStyle xmlns:a="http://schemas.openxmlformats.org/drawingml/2006/main"/>
+          <a:p xmlns:a="http://schemas.openxmlformats.org/drawingml/2006/main">
+            <a:r>
+              <a:t>[PUNTERO: señalar VIF máximo 1,239, luego el valor p de edad y finalmente las líneas de referencia de los gráficos.]</a:t>
+            </a:r>
+          </a:p>
+          <a:p xmlns:a="http://schemas.openxmlformats.org/drawingml/2006/main">
+            <a:r>
+              <a:t/>
+            </a:r>
+          </a:p>
           <a:p xmlns:a="http://schemas.openxmlformats.org/drawingml/2006/main">
             <a:r>
               <a:t>Los diagnósticos muestran dónde el modelo puede simplificar demasiado la realidad. El VIF máximo fue 1,239, muy por debajo del umbral práctico de cinco, por lo que no observamos multicolinealidad preocupante. La prueba de Box-Tidwell detectó no linealidad para la edad, con p igual a 0,0154. También identificamos observaciones influyentes mediante distancia de Cook y residuos de Pearson. Al retirarlas, los signos se mantuvieron, pero aumentaron algunas magnitudes. No eliminamos estos casos automáticamente porque pueden representar personas reales. La recomendación principal es modelar la edad con una forma más flexible.</a:t>
@@ -1171,6 +1311,16 @@
           <a:lstStyle xmlns:a="http://schemas.openxmlformats.org/drawingml/2006/main"/>
           <a:p xmlns:a="http://schemas.openxmlformats.org/drawingml/2006/main">
             <a:r>
+              <a:t>[PUNTERO: señalar los tres valores de AUC de la izquierda. Después recorrer brevemente las barras y los intervalos del gráfico.]</a:t>
+            </a:r>
+          </a:p>
+          <a:p xmlns:a="http://schemas.openxmlformats.org/drawingml/2006/main">
+            <a:r>
+              <a:t/>
+            </a:r>
+          </a:p>
+          <a:p xmlns:a="http://schemas.openxmlformats.org/drawingml/2006/main">
+            <a:r>
               <a:t>Por último, ajustamos M3 con las tres estrategias de datos faltantes y comparamos las versiones sobre las mismas 1.117 personas completas de prueba. Los valores de AUC fueron 0,7073 para eliminación y 0,7059 para ambas imputaciones. Los intervalos de los coeficientes también se superpusieron. Esto indica que la conclusión general cambió poco. La eliminación perdió 427 observaciones de entrenamiento y no entregó una ventaja clara. Sin embargo, esta comparación utiliza casos completos en prueba, de modo que no permite saber qué método imputaría mejor a una persona nueva con información faltante.</a:t>
             </a:r>
           </a:p>
@@ -1228,7 +1378,7 @@
           <p:cNvPr id="3" name="Title">
             <a:extLst xmlns:a="http://schemas.openxmlformats.org/drawingml/2006/main">
               <a:ext uri="{FF2B5EF4-FFF2-40B4-BE49-F238E27FC236}">
-                <a16:creationId xmlns:a16="http://schemas.microsoft.com/office/drawing/2014/main" id="{DC7A2B1E-2272-42C8-9D91-D852B3058F41}"/>
+                <a16:creationId xmlns:a16="http://schemas.microsoft.com/office/drawing/2014/main" id="{E3A40133-E558-41BD-AE6F-6DF23EB5AC82}"/>
               </a:ext>
             </a:extLst>
           </p:cNvPr>
@@ -1457,7 +1607,7 @@
           <p:cNvPr id="2" name="Subtitle">
             <a:extLst xmlns:a="http://schemas.openxmlformats.org/drawingml/2006/main">
               <a:ext uri="{FF2B5EF4-FFF2-40B4-BE49-F238E27FC236}">
-                <a16:creationId xmlns:a16="http://schemas.microsoft.com/office/drawing/2014/main" id="{C7FEEF68-462C-40EB-9F37-628154D0C8F7}"/>
+                <a16:creationId xmlns:a16="http://schemas.microsoft.com/office/drawing/2014/main" id="{BB33CDA4-078E-495F-BD6F-554DA13CB884}"/>
               </a:ext>
             </a:extLst>
           </p:cNvPr>
@@ -1703,7 +1853,7 @@
           <p:cNvPr id="2" name="Section title">
             <a:extLst xmlns:a="http://schemas.openxmlformats.org/drawingml/2006/main">
               <a:ext uri="{FF2B5EF4-FFF2-40B4-BE49-F238E27FC236}">
-                <a16:creationId xmlns:a16="http://schemas.microsoft.com/office/drawing/2014/main" id="{FF91D5F3-902C-4C0F-AB73-E0D6F33FEB02}"/>
+                <a16:creationId xmlns:a16="http://schemas.microsoft.com/office/drawing/2014/main" id="{ABF1DB01-10B5-416F-8E6E-F6BCAF587376}"/>
               </a:ext>
             </a:extLst>
           </p:cNvPr>
@@ -1949,7 +2099,7 @@
           <p:cNvPr id="3" name="Title">
             <a:extLst xmlns:a="http://schemas.openxmlformats.org/drawingml/2006/main">
               <a:ext uri="{FF2B5EF4-FFF2-40B4-BE49-F238E27FC236}">
-                <a16:creationId xmlns:a16="http://schemas.microsoft.com/office/drawing/2014/main" id="{5E73D8A2-133D-4AAA-81A7-C181356A70B4}"/>
+                <a16:creationId xmlns:a16="http://schemas.microsoft.com/office/drawing/2014/main" id="{92F34D6B-6FF5-417C-ADA3-FA7DEAAA0AF5}"/>
               </a:ext>
             </a:extLst>
           </p:cNvPr>
@@ -2178,7 +2328,7 @@
           <p:cNvPr id="2" name="Body">
             <a:extLst xmlns:a="http://schemas.openxmlformats.org/drawingml/2006/main">
               <a:ext uri="{FF2B5EF4-FFF2-40B4-BE49-F238E27FC236}">
-                <a16:creationId xmlns:a16="http://schemas.microsoft.com/office/drawing/2014/main" id="{C95744CA-DA69-4A92-BA92-31F20754CAA9}"/>
+                <a16:creationId xmlns:a16="http://schemas.microsoft.com/office/drawing/2014/main" id="{2FE2CAD0-A71B-419F-B8BD-F126D51E71B0}"/>
               </a:ext>
             </a:extLst>
           </p:cNvPr>
@@ -2424,7 +2574,7 @@
           <p:cNvPr id="4" name="Title">
             <a:extLst xmlns:a="http://schemas.openxmlformats.org/drawingml/2006/main">
               <a:ext uri="{FF2B5EF4-FFF2-40B4-BE49-F238E27FC236}">
-                <a16:creationId xmlns:a16="http://schemas.microsoft.com/office/drawing/2014/main" id="{9A8FE74C-D129-46D7-8D3E-8BA748DCEC8D}"/>
+                <a16:creationId xmlns:a16="http://schemas.microsoft.com/office/drawing/2014/main" id="{FCDD86CB-87A2-4CE0-9EFA-4D9929F105A2}"/>
               </a:ext>
             </a:extLst>
           </p:cNvPr>
@@ -2653,7 +2803,7 @@
           <p:cNvPr id="2" name="Left column">
             <a:extLst xmlns:a="http://schemas.openxmlformats.org/drawingml/2006/main">
               <a:ext uri="{FF2B5EF4-FFF2-40B4-BE49-F238E27FC236}">
-                <a16:creationId xmlns:a16="http://schemas.microsoft.com/office/drawing/2014/main" id="{1EEF11B1-4D77-43D1-BE7B-C9E62A5CA6FF}"/>
+                <a16:creationId xmlns:a16="http://schemas.microsoft.com/office/drawing/2014/main" id="{6711C8D9-34D5-4AB6-BC76-6B43C1D65EBA}"/>
               </a:ext>
             </a:extLst>
           </p:cNvPr>
@@ -2882,7 +3032,7 @@
           <p:cNvPr id="3" name="Right column">
             <a:extLst xmlns:a="http://schemas.openxmlformats.org/drawingml/2006/main">
               <a:ext uri="{FF2B5EF4-FFF2-40B4-BE49-F238E27FC236}">
-                <a16:creationId xmlns:a16="http://schemas.microsoft.com/office/drawing/2014/main" id="{059297A1-CCEE-4AFC-8578-10026E2F4CFB}"/>
+                <a16:creationId xmlns:a16="http://schemas.microsoft.com/office/drawing/2014/main" id="{D9B0681E-0A55-49DC-ABBF-6439656FDC74}"/>
               </a:ext>
             </a:extLst>
           </p:cNvPr>
@@ -3128,7 +3278,7 @@
           <p:cNvPr id="3" name="Title">
             <a:extLst xmlns:a="http://schemas.openxmlformats.org/drawingml/2006/main">
               <a:ext uri="{FF2B5EF4-FFF2-40B4-BE49-F238E27FC236}">
-                <a16:creationId xmlns:a16="http://schemas.microsoft.com/office/drawing/2014/main" id="{C007BC38-736F-49ED-AF7C-77A9A2AA3B8F}"/>
+                <a16:creationId xmlns:a16="http://schemas.microsoft.com/office/drawing/2014/main" id="{C8225210-D4B2-4D35-911F-990531931EB1}"/>
               </a:ext>
             </a:extLst>
           </p:cNvPr>
@@ -3357,7 +3507,7 @@
           <p:cNvPr id="2" name="Left column">
             <a:extLst xmlns:a="http://schemas.openxmlformats.org/drawingml/2006/main">
               <a:ext uri="{FF2B5EF4-FFF2-40B4-BE49-F238E27FC236}">
-                <a16:creationId xmlns:a16="http://schemas.microsoft.com/office/drawing/2014/main" id="{3D022287-2DA4-4D6C-913A-800662F33626}"/>
+                <a16:creationId xmlns:a16="http://schemas.microsoft.com/office/drawing/2014/main" id="{07F678B2-281E-43E1-B725-AFE944B8CDD1}"/>
               </a:ext>
             </a:extLst>
           </p:cNvPr>
@@ -3624,12 +3774,12 @@
   </p:cSld>
   <p:clrMap bg1="lt1" tx1="dk1" bg2="lt2" tx2="dk2" accent1="accent1" accent2="accent2" accent3="accent3" accent4="accent4" accent5="accent5" accent6="accent6" hlink="hlink" folHlink="folHlink"/>
   <p:sldLayoutIdLst>
-    <p:sldLayoutId xmlns:r="http://schemas.openxmlformats.org/officeDocument/2006/relationships" id="2147483649" r:id="Rc26da81fc8f34e53"/>
-    <p:sldLayoutId xmlns:r="http://schemas.openxmlformats.org/officeDocument/2006/relationships" id="2147483650" r:id="R636434fcda0e4a5d"/>
-    <p:sldLayoutId xmlns:r="http://schemas.openxmlformats.org/officeDocument/2006/relationships" id="2147483651" r:id="R8671d9a383d148d2"/>
-    <p:sldLayoutId xmlns:r="http://schemas.openxmlformats.org/officeDocument/2006/relationships" id="2147483652" r:id="Ra29f044bf2344764"/>
-    <p:sldLayoutId xmlns:r="http://schemas.openxmlformats.org/officeDocument/2006/relationships" id="2147483653" r:id="Rec8794d13e0c492d"/>
-    <p:sldLayoutId xmlns:r="http://schemas.openxmlformats.org/officeDocument/2006/relationships" id="2147483654" r:id="R6562671f910543c6"/>
+    <p:sldLayoutId xmlns:r="http://schemas.openxmlformats.org/officeDocument/2006/relationships" id="2147483649" r:id="R6f30c2e15400435b"/>
+    <p:sldLayoutId xmlns:r="http://schemas.openxmlformats.org/officeDocument/2006/relationships" id="2147483650" r:id="Ra77c46aedb474067"/>
+    <p:sldLayoutId xmlns:r="http://schemas.openxmlformats.org/officeDocument/2006/relationships" id="2147483651" r:id="R680f59685138498f"/>
+    <p:sldLayoutId xmlns:r="http://schemas.openxmlformats.org/officeDocument/2006/relationships" id="2147483652" r:id="R6e7eab44fbc74eec"/>
+    <p:sldLayoutId xmlns:r="http://schemas.openxmlformats.org/officeDocument/2006/relationships" id="2147483653" r:id="Rb9dbb763790c4c6c"/>
+    <p:sldLayoutId xmlns:r="http://schemas.openxmlformats.org/officeDocument/2006/relationships" id="2147483654" r:id="R7cc7fbeb75fc4183"/>
   </p:sldLayoutIdLst>
   <p:txStyles>
     <p:titleStyle>
@@ -4180,7 +4330,7 @@
           <p:cNvPr id="10" name="">
             <a:extLst xmlns:a="http://schemas.openxmlformats.org/drawingml/2006/main">
               <a:ext uri="{FF2B5EF4-FFF2-40B4-BE49-F238E27FC236}">
-                <a16:creationId xmlns:a16="http://schemas.microsoft.com/office/drawing/2014/main" id="{FAA1C67B-53F3-4030-9099-CFEA6F8587E1}"/>
+                <a16:creationId xmlns:a16="http://schemas.microsoft.com/office/drawing/2014/main" id="{62613D38-30F1-4B5F-8631-77E81B88A4F7}"/>
               </a:ext>
             </a:extLst>
           </p:cNvPr>
@@ -4211,7 +4361,7 @@
           <p:cNvPr id="2" name="">
             <a:extLst xmlns:a="http://schemas.openxmlformats.org/drawingml/2006/main">
               <a:ext uri="{FF2B5EF4-FFF2-40B4-BE49-F238E27FC236}">
-                <a16:creationId xmlns:a16="http://schemas.microsoft.com/office/drawing/2014/main" id="{070B3F93-FC1C-40B0-874E-4E92B0D2E9F1}"/>
+                <a16:creationId xmlns:a16="http://schemas.microsoft.com/office/drawing/2014/main" id="{E594EA7E-2299-4145-B718-091F6E090DDF}"/>
               </a:ext>
             </a:extLst>
           </p:cNvPr>
@@ -4221,7 +4371,7 @@
           <p:nvPr/>
         </p:nvPicPr>
         <p:blipFill>
-          <a:blip xmlns:r="http://schemas.openxmlformats.org/officeDocument/2006/relationships" xmlns:a="http://schemas.openxmlformats.org/drawingml/2006/main" r:embed="R03c23b49464c4ca8"/>
+          <a:blip xmlns:r="http://schemas.openxmlformats.org/officeDocument/2006/relationships" xmlns:a="http://schemas.openxmlformats.org/drawingml/2006/main" r:embed="R3f2bbb8d874b4b9d"/>
           <a:stretch xmlns:a="http://schemas.openxmlformats.org/drawingml/2006/main"/>
         </p:blipFill>
         <p:spPr>
@@ -4239,7 +4389,7 @@
           <p:cNvPr id="3" name="">
             <a:extLst xmlns:a="http://schemas.openxmlformats.org/drawingml/2006/main">
               <a:ext uri="{FF2B5EF4-FFF2-40B4-BE49-F238E27FC236}">
-                <a16:creationId xmlns:a16="http://schemas.microsoft.com/office/drawing/2014/main" id="{E59E0B45-3005-440D-9DA6-8EC7CE8A9C23}"/>
+                <a16:creationId xmlns:a16="http://schemas.microsoft.com/office/drawing/2014/main" id="{FD96F416-F406-464C-97DF-096D4F78A3E2}"/>
               </a:ext>
             </a:extLst>
           </p:cNvPr>
@@ -4360,7 +4510,7 @@
           <p:cNvPr id="4" name="">
             <a:extLst xmlns:a="http://schemas.openxmlformats.org/drawingml/2006/main">
               <a:ext uri="{FF2B5EF4-FFF2-40B4-BE49-F238E27FC236}">
-                <a16:creationId xmlns:a16="http://schemas.microsoft.com/office/drawing/2014/main" id="{30BE7501-41FA-4456-99B0-D1AE2EF17183}"/>
+                <a16:creationId xmlns:a16="http://schemas.microsoft.com/office/drawing/2014/main" id="{0C238E78-5E6F-4C43-9984-1B1BBDAC6AEE}"/>
               </a:ext>
             </a:extLst>
           </p:cNvPr>
@@ -4481,7 +4631,7 @@
           <p:cNvPr id="5" name="">
             <a:extLst xmlns:a="http://schemas.openxmlformats.org/drawingml/2006/main">
               <a:ext uri="{FF2B5EF4-FFF2-40B4-BE49-F238E27FC236}">
-                <a16:creationId xmlns:a16="http://schemas.microsoft.com/office/drawing/2014/main" id="{A613A989-4E30-42B0-A382-B10DF7BE4CC2}"/>
+                <a16:creationId xmlns:a16="http://schemas.microsoft.com/office/drawing/2014/main" id="{3C4C08FD-5D43-4B13-B418-49875074E9C1}"/>
               </a:ext>
             </a:extLst>
           </p:cNvPr>
@@ -4602,7 +4752,7 @@
           <p:cNvPr id="6" name="">
             <a:extLst xmlns:a="http://schemas.openxmlformats.org/drawingml/2006/main">
               <a:ext uri="{FF2B5EF4-FFF2-40B4-BE49-F238E27FC236}">
-                <a16:creationId xmlns:a16="http://schemas.microsoft.com/office/drawing/2014/main" id="{A4710DC3-A24B-4B9B-9AD9-39AAE7768F8D}"/>
+                <a16:creationId xmlns:a16="http://schemas.microsoft.com/office/drawing/2014/main" id="{6C9F4745-C19E-46BF-8244-91DD4FDD448D}"/>
               </a:ext>
             </a:extLst>
           </p:cNvPr>
@@ -4633,7 +4783,7 @@
           <p:cNvPr id="7" name="">
             <a:extLst xmlns:a="http://schemas.openxmlformats.org/drawingml/2006/main">
               <a:ext uri="{FF2B5EF4-FFF2-40B4-BE49-F238E27FC236}">
-                <a16:creationId xmlns:a16="http://schemas.microsoft.com/office/drawing/2014/main" id="{10947EDA-9560-4C22-9D84-F6839A2B5A65}"/>
+                <a16:creationId xmlns:a16="http://schemas.microsoft.com/office/drawing/2014/main" id="{54213D4C-B117-4296-9D46-2867CA31D9E8}"/>
               </a:ext>
             </a:extLst>
           </p:cNvPr>
@@ -4754,7 +4904,7 @@
           <p:cNvPr id="8" name="">
             <a:extLst xmlns:a="http://schemas.openxmlformats.org/drawingml/2006/main">
               <a:ext uri="{FF2B5EF4-FFF2-40B4-BE49-F238E27FC236}">
-                <a16:creationId xmlns:a16="http://schemas.microsoft.com/office/drawing/2014/main" id="{A6449991-72E8-4D85-BC3B-91CF4BFD67B5}"/>
+                <a16:creationId xmlns:a16="http://schemas.microsoft.com/office/drawing/2014/main" id="{49AB9F1A-A1FE-461C-97BE-B529D9F1C5F5}"/>
               </a:ext>
             </a:extLst>
           </p:cNvPr>
@@ -4875,7 +5025,7 @@
           <p:cNvPr id="9" name="">
             <a:extLst xmlns:a="http://schemas.openxmlformats.org/drawingml/2006/main">
               <a:ext uri="{FF2B5EF4-FFF2-40B4-BE49-F238E27FC236}">
-                <a16:creationId xmlns:a16="http://schemas.microsoft.com/office/drawing/2014/main" id="{DD7B0B17-2C90-4836-9326-67808483D099}"/>
+                <a16:creationId xmlns:a16="http://schemas.microsoft.com/office/drawing/2014/main" id="{EF139C15-940A-43A6-936B-1A3FB935D152}"/>
               </a:ext>
             </a:extLst>
           </p:cNvPr>
@@ -4994,7 +5144,7 @@
     </p:spTree>
     <p:extLst>
       <p:ext uri="{BB962C8B-B14F-4D97-AF65-F5344CB8AC3E}">
-        <p14:creationId xmlns:p14="http://schemas.microsoft.com/office/powerpoint/2010/main" val="292671372"/>
+        <p14:creationId xmlns:p14="http://schemas.microsoft.com/office/powerpoint/2010/main" val="1557571325"/>
       </p:ext>
     </p:extLst>
   </p:cSld>
@@ -5025,7 +5175,7 @@
           <p:cNvPr id="12" name="">
             <a:extLst xmlns:a="http://schemas.openxmlformats.org/drawingml/2006/main">
               <a:ext uri="{FF2B5EF4-FFF2-40B4-BE49-F238E27FC236}">
-                <a16:creationId xmlns:a16="http://schemas.microsoft.com/office/drawing/2014/main" id="{553F609A-A3AA-4BB8-9C9B-39C67666B6ED}"/>
+                <a16:creationId xmlns:a16="http://schemas.microsoft.com/office/drawing/2014/main" id="{93959D75-4E0C-43C4-B395-699FBECF5A84}"/>
               </a:ext>
             </a:extLst>
           </p:cNvPr>
@@ -5146,7 +5296,7 @@
           <p:cNvPr id="2" name="">
             <a:extLst xmlns:a="http://schemas.openxmlformats.org/drawingml/2006/main">
               <a:ext uri="{FF2B5EF4-FFF2-40B4-BE49-F238E27FC236}">
-                <a16:creationId xmlns:a16="http://schemas.microsoft.com/office/drawing/2014/main" id="{949C3C03-C4C3-4A70-8773-B06107A4041D}"/>
+                <a16:creationId xmlns:a16="http://schemas.microsoft.com/office/drawing/2014/main" id="{0740822F-19BA-481B-9720-07A7F1E833CF}"/>
               </a:ext>
             </a:extLst>
           </p:cNvPr>
@@ -5177,7 +5327,7 @@
           <p:cNvPr id="3" name="">
             <a:extLst xmlns:a="http://schemas.openxmlformats.org/drawingml/2006/main">
               <a:ext uri="{FF2B5EF4-FFF2-40B4-BE49-F238E27FC236}">
-                <a16:creationId xmlns:a16="http://schemas.microsoft.com/office/drawing/2014/main" id="{42E5E224-A1E5-48DC-A29C-E45AE954CDE9}"/>
+                <a16:creationId xmlns:a16="http://schemas.microsoft.com/office/drawing/2014/main" id="{A618BF11-66D4-46FC-B815-2352BA70A931}"/>
               </a:ext>
             </a:extLst>
           </p:cNvPr>
@@ -5298,7 +5448,7 @@
           <p:cNvPr id="4" name="">
             <a:extLst xmlns:a="http://schemas.openxmlformats.org/drawingml/2006/main">
               <a:ext uri="{FF2B5EF4-FFF2-40B4-BE49-F238E27FC236}">
-                <a16:creationId xmlns:a16="http://schemas.microsoft.com/office/drawing/2014/main" id="{50CE6773-2798-433C-96B1-906B7123CF25}"/>
+                <a16:creationId xmlns:a16="http://schemas.microsoft.com/office/drawing/2014/main" id="{379A40C5-3F23-461C-8CA3-3AD8C3B4FA71}"/>
               </a:ext>
             </a:extLst>
           </p:cNvPr>
@@ -5419,7 +5569,7 @@
           <p:cNvPr id="5" name="">
             <a:extLst xmlns:a="http://schemas.openxmlformats.org/drawingml/2006/main">
               <a:ext uri="{FF2B5EF4-FFF2-40B4-BE49-F238E27FC236}">
-                <a16:creationId xmlns:a16="http://schemas.microsoft.com/office/drawing/2014/main" id="{493444A6-40E0-4D76-8241-588B5E26151F}"/>
+                <a16:creationId xmlns:a16="http://schemas.microsoft.com/office/drawing/2014/main" id="{72963E61-A5DB-41B9-BE50-5E7C68A82CAE}"/>
               </a:ext>
             </a:extLst>
           </p:cNvPr>
@@ -5584,7 +5734,7 @@
           <p:cNvPr id="6" name="">
             <a:extLst xmlns:a="http://schemas.openxmlformats.org/drawingml/2006/main">
               <a:ext uri="{FF2B5EF4-FFF2-40B4-BE49-F238E27FC236}">
-                <a16:creationId xmlns:a16="http://schemas.microsoft.com/office/drawing/2014/main" id="{9127EF99-C989-4066-897D-0C6062650FC3}"/>
+                <a16:creationId xmlns:a16="http://schemas.microsoft.com/office/drawing/2014/main" id="{BA278B0C-D2AB-4DDC-8C35-5FA44BDED0CF}"/>
               </a:ext>
             </a:extLst>
           </p:cNvPr>
@@ -5617,7 +5767,7 @@
           <p:cNvPr id="7" name="">
             <a:extLst xmlns:a="http://schemas.openxmlformats.org/drawingml/2006/main">
               <a:ext uri="{FF2B5EF4-FFF2-40B4-BE49-F238E27FC236}">
-                <a16:creationId xmlns:a16="http://schemas.microsoft.com/office/drawing/2014/main" id="{35EF4C45-2F08-422B-B9BC-C3992CB75D1D}"/>
+                <a16:creationId xmlns:a16="http://schemas.microsoft.com/office/drawing/2014/main" id="{3EE23844-DE70-4705-9AFA-ECC26712F218}"/>
               </a:ext>
             </a:extLst>
           </p:cNvPr>
@@ -5738,7 +5888,7 @@
           <p:cNvPr id="8" name="">
             <a:extLst xmlns:a="http://schemas.openxmlformats.org/drawingml/2006/main">
               <a:ext uri="{FF2B5EF4-FFF2-40B4-BE49-F238E27FC236}">
-                <a16:creationId xmlns:a16="http://schemas.microsoft.com/office/drawing/2014/main" id="{EB0D4013-0BDF-44B4-B57E-395B3A93D625}"/>
+                <a16:creationId xmlns:a16="http://schemas.microsoft.com/office/drawing/2014/main" id="{953FAB54-B013-4BB9-B993-AFCB45BB06A2}"/>
               </a:ext>
             </a:extLst>
           </p:cNvPr>
@@ -5947,7 +6097,7 @@
           <p:cNvPr id="9" name="">
             <a:extLst xmlns:a="http://schemas.openxmlformats.org/drawingml/2006/main">
               <a:ext uri="{FF2B5EF4-FFF2-40B4-BE49-F238E27FC236}">
-                <a16:creationId xmlns:a16="http://schemas.microsoft.com/office/drawing/2014/main" id="{27C2A7EC-38D4-4BE6-BEF1-7DC3B4864D53}"/>
+                <a16:creationId xmlns:a16="http://schemas.microsoft.com/office/drawing/2014/main" id="{9E8131EF-3083-4937-BA6F-8757B3B0948C}"/>
               </a:ext>
             </a:extLst>
           </p:cNvPr>
@@ -5980,7 +6130,7 @@
           <p:cNvPr id="10" name="">
             <a:extLst xmlns:a="http://schemas.openxmlformats.org/drawingml/2006/main">
               <a:ext uri="{FF2B5EF4-FFF2-40B4-BE49-F238E27FC236}">
-                <a16:creationId xmlns:a16="http://schemas.microsoft.com/office/drawing/2014/main" id="{F89FEDA6-72CC-4EC3-92A1-C17CDE790E27}"/>
+                <a16:creationId xmlns:a16="http://schemas.microsoft.com/office/drawing/2014/main" id="{2C508567-A99E-41FA-98D1-9A6DB9215F8A}"/>
               </a:ext>
             </a:extLst>
           </p:cNvPr>
@@ -6101,7 +6251,7 @@
           <p:cNvPr id="11" name="">
             <a:extLst xmlns:a="http://schemas.openxmlformats.org/drawingml/2006/main">
               <a:ext uri="{FF2B5EF4-FFF2-40B4-BE49-F238E27FC236}">
-                <a16:creationId xmlns:a16="http://schemas.microsoft.com/office/drawing/2014/main" id="{0CD89D2B-48FF-4025-9ADF-986F304DE44E}"/>
+                <a16:creationId xmlns:a16="http://schemas.microsoft.com/office/drawing/2014/main" id="{633AFC82-7215-47D5-9B2E-2815277A901C}"/>
               </a:ext>
             </a:extLst>
           </p:cNvPr>
@@ -6220,7 +6370,7 @@
     </p:spTree>
     <p:extLst>
       <p:ext uri="{BB962C8B-B14F-4D97-AF65-F5344CB8AC3E}">
-        <p14:creationId xmlns:p14="http://schemas.microsoft.com/office/powerpoint/2010/main" val="600380198"/>
+        <p14:creationId xmlns:p14="http://schemas.microsoft.com/office/powerpoint/2010/main" val="1215311328"/>
       </p:ext>
     </p:extLst>
   </p:cSld>
@@ -6251,7 +6401,7 @@
           <p:cNvPr id="18" name="">
             <a:extLst xmlns:a="http://schemas.openxmlformats.org/drawingml/2006/main">
               <a:ext uri="{FF2B5EF4-FFF2-40B4-BE49-F238E27FC236}">
-                <a16:creationId xmlns:a16="http://schemas.microsoft.com/office/drawing/2014/main" id="{083C49E6-FE26-4145-A8ED-6BAE571A5C71}"/>
+                <a16:creationId xmlns:a16="http://schemas.microsoft.com/office/drawing/2014/main" id="{3A441092-7588-4191-9868-93C7BA60EFF9}"/>
               </a:ext>
             </a:extLst>
           </p:cNvPr>
@@ -6372,7 +6522,7 @@
           <p:cNvPr id="2" name="">
             <a:extLst xmlns:a="http://schemas.openxmlformats.org/drawingml/2006/main">
               <a:ext uri="{FF2B5EF4-FFF2-40B4-BE49-F238E27FC236}">
-                <a16:creationId xmlns:a16="http://schemas.microsoft.com/office/drawing/2014/main" id="{F7BA1F5A-D604-454C-A37C-160F1DE6DB04}"/>
+                <a16:creationId xmlns:a16="http://schemas.microsoft.com/office/drawing/2014/main" id="{0C3EAE92-B0A9-4610-B9C9-783CB6589843}"/>
               </a:ext>
             </a:extLst>
           </p:cNvPr>
@@ -6403,7 +6553,7 @@
           <p:cNvPr id="3" name="">
             <a:extLst xmlns:a="http://schemas.openxmlformats.org/drawingml/2006/main">
               <a:ext uri="{FF2B5EF4-FFF2-40B4-BE49-F238E27FC236}">
-                <a16:creationId xmlns:a16="http://schemas.microsoft.com/office/drawing/2014/main" id="{822A7494-7D16-4D1A-86EC-519D1A871D36}"/>
+                <a16:creationId xmlns:a16="http://schemas.microsoft.com/office/drawing/2014/main" id="{C0CA268D-A3DF-41B7-B557-1D81A4EC8C19}"/>
               </a:ext>
             </a:extLst>
           </p:cNvPr>
@@ -6524,7 +6674,7 @@
           <p:cNvPr id="4" name="">
             <a:extLst xmlns:a="http://schemas.openxmlformats.org/drawingml/2006/main">
               <a:ext uri="{FF2B5EF4-FFF2-40B4-BE49-F238E27FC236}">
-                <a16:creationId xmlns:a16="http://schemas.microsoft.com/office/drawing/2014/main" id="{9A7AB0E2-9496-4C48-B1EF-F05E19FF8FCE}"/>
+                <a16:creationId xmlns:a16="http://schemas.microsoft.com/office/drawing/2014/main" id="{EE2EAE7C-D45F-410D-8336-F72D153E69F1}"/>
               </a:ext>
             </a:extLst>
           </p:cNvPr>
@@ -6645,7 +6795,7 @@
           <p:cNvPr id="5" name="">
             <a:extLst xmlns:a="http://schemas.openxmlformats.org/drawingml/2006/main">
               <a:ext uri="{FF2B5EF4-FFF2-40B4-BE49-F238E27FC236}">
-                <a16:creationId xmlns:a16="http://schemas.microsoft.com/office/drawing/2014/main" id="{42B02BC5-26BD-4054-9568-35F6E7B6931D}"/>
+                <a16:creationId xmlns:a16="http://schemas.microsoft.com/office/drawing/2014/main" id="{F8A9B338-912D-40D8-931B-F932CA4433FE}"/>
               </a:ext>
             </a:extLst>
           </p:cNvPr>
@@ -6766,7 +6916,7 @@
           <p:cNvPr id="6" name="">
             <a:extLst xmlns:a="http://schemas.openxmlformats.org/drawingml/2006/main">
               <a:ext uri="{FF2B5EF4-FFF2-40B4-BE49-F238E27FC236}">
-                <a16:creationId xmlns:a16="http://schemas.microsoft.com/office/drawing/2014/main" id="{70F9A629-D0D6-4F35-91A7-73D18F20A880}"/>
+                <a16:creationId xmlns:a16="http://schemas.microsoft.com/office/drawing/2014/main" id="{85CBE6BC-5496-4A58-8344-3E6A0E3A2B7C}"/>
               </a:ext>
             </a:extLst>
           </p:cNvPr>
@@ -6887,7 +7037,7 @@
           <p:cNvPr id="7" name="">
             <a:extLst xmlns:a="http://schemas.openxmlformats.org/drawingml/2006/main">
               <a:ext uri="{FF2B5EF4-FFF2-40B4-BE49-F238E27FC236}">
-                <a16:creationId xmlns:a16="http://schemas.microsoft.com/office/drawing/2014/main" id="{5DDC5D8E-7212-4EEE-8BC1-41D78D92C10C}"/>
+                <a16:creationId xmlns:a16="http://schemas.microsoft.com/office/drawing/2014/main" id="{1841ACC3-4D30-41FB-AE21-41F1488A0E72}"/>
               </a:ext>
             </a:extLst>
           </p:cNvPr>
@@ -6920,7 +7070,7 @@
           <p:cNvPr id="8" name="">
             <a:extLst xmlns:a="http://schemas.openxmlformats.org/drawingml/2006/main">
               <a:ext uri="{FF2B5EF4-FFF2-40B4-BE49-F238E27FC236}">
-                <a16:creationId xmlns:a16="http://schemas.microsoft.com/office/drawing/2014/main" id="{876D924A-4607-4B89-B562-28420E28AFAE}"/>
+                <a16:creationId xmlns:a16="http://schemas.microsoft.com/office/drawing/2014/main" id="{490B11D1-3E0B-4385-8B0B-9E4EAA6FD363}"/>
               </a:ext>
             </a:extLst>
           </p:cNvPr>
@@ -7041,7 +7191,7 @@
           <p:cNvPr id="9" name="">
             <a:extLst xmlns:a="http://schemas.openxmlformats.org/drawingml/2006/main">
               <a:ext uri="{FF2B5EF4-FFF2-40B4-BE49-F238E27FC236}">
-                <a16:creationId xmlns:a16="http://schemas.microsoft.com/office/drawing/2014/main" id="{F8121338-0762-4CB4-9A47-24A1822CBE7C}"/>
+                <a16:creationId xmlns:a16="http://schemas.microsoft.com/office/drawing/2014/main" id="{EE7D52B0-2C35-417E-8034-83E045B27758}"/>
               </a:ext>
             </a:extLst>
           </p:cNvPr>
@@ -7162,7 +7312,7 @@
           <p:cNvPr id="10" name="">
             <a:extLst xmlns:a="http://schemas.openxmlformats.org/drawingml/2006/main">
               <a:ext uri="{FF2B5EF4-FFF2-40B4-BE49-F238E27FC236}">
-                <a16:creationId xmlns:a16="http://schemas.microsoft.com/office/drawing/2014/main" id="{285D8D07-5352-44D3-95B3-E96E0D03BD3D}"/>
+                <a16:creationId xmlns:a16="http://schemas.microsoft.com/office/drawing/2014/main" id="{66481B18-5DA3-447A-A965-75376FD1CA4F}"/>
               </a:ext>
             </a:extLst>
           </p:cNvPr>
@@ -7283,7 +7433,7 @@
           <p:cNvPr id="11" name="">
             <a:extLst xmlns:a="http://schemas.openxmlformats.org/drawingml/2006/main">
               <a:ext uri="{FF2B5EF4-FFF2-40B4-BE49-F238E27FC236}">
-                <a16:creationId xmlns:a16="http://schemas.microsoft.com/office/drawing/2014/main" id="{DEFBA1BF-A81C-4714-B6D5-E288857BC6C2}"/>
+                <a16:creationId xmlns:a16="http://schemas.microsoft.com/office/drawing/2014/main" id="{4B2740EB-03AC-4125-8451-6E7642FD8265}"/>
               </a:ext>
             </a:extLst>
           </p:cNvPr>
@@ -7404,7 +7554,7 @@
           <p:cNvPr id="12" name="">
             <a:extLst xmlns:a="http://schemas.openxmlformats.org/drawingml/2006/main">
               <a:ext uri="{FF2B5EF4-FFF2-40B4-BE49-F238E27FC236}">
-                <a16:creationId xmlns:a16="http://schemas.microsoft.com/office/drawing/2014/main" id="{C1C308A9-837B-4FEF-8947-43DAB405ECF7}"/>
+                <a16:creationId xmlns:a16="http://schemas.microsoft.com/office/drawing/2014/main" id="{61A13A57-A19F-4332-9D20-328D8B09F76C}"/>
               </a:ext>
             </a:extLst>
           </p:cNvPr>
@@ -7525,7 +7675,7 @@
           <p:cNvPr id="13" name="">
             <a:extLst xmlns:a="http://schemas.openxmlformats.org/drawingml/2006/main">
               <a:ext uri="{FF2B5EF4-FFF2-40B4-BE49-F238E27FC236}">
-                <a16:creationId xmlns:a16="http://schemas.microsoft.com/office/drawing/2014/main" id="{DC7A1FA8-5E6A-400E-9B79-325546CAB283}"/>
+                <a16:creationId xmlns:a16="http://schemas.microsoft.com/office/drawing/2014/main" id="{DF90A144-5318-4AD4-BD34-109CBAC60C41}"/>
               </a:ext>
             </a:extLst>
           </p:cNvPr>
@@ -7646,7 +7796,7 @@
           <p:cNvPr id="14" name="">
             <a:extLst xmlns:a="http://schemas.openxmlformats.org/drawingml/2006/main">
               <a:ext uri="{FF2B5EF4-FFF2-40B4-BE49-F238E27FC236}">
-                <a16:creationId xmlns:a16="http://schemas.microsoft.com/office/drawing/2014/main" id="{1EADA142-2CDB-4F4D-8B8B-1521C673730E}"/>
+                <a16:creationId xmlns:a16="http://schemas.microsoft.com/office/drawing/2014/main" id="{D16E26C3-D56F-45B0-A7D7-27F0742575CE}"/>
               </a:ext>
             </a:extLst>
           </p:cNvPr>
@@ -7767,7 +7917,7 @@
           <p:cNvPr id="15" name="">
             <a:extLst xmlns:a="http://schemas.openxmlformats.org/drawingml/2006/main">
               <a:ext uri="{FF2B5EF4-FFF2-40B4-BE49-F238E27FC236}">
-                <a16:creationId xmlns:a16="http://schemas.microsoft.com/office/drawing/2014/main" id="{9E588101-04BF-483D-9086-7ABA1B7485DD}"/>
+                <a16:creationId xmlns:a16="http://schemas.microsoft.com/office/drawing/2014/main" id="{2BB62D0F-627C-4FDB-9570-0E0E94388975}"/>
               </a:ext>
             </a:extLst>
           </p:cNvPr>
@@ -7888,7 +8038,7 @@
           <p:cNvPr id="16" name="">
             <a:extLst xmlns:a="http://schemas.openxmlformats.org/drawingml/2006/main">
               <a:ext uri="{FF2B5EF4-FFF2-40B4-BE49-F238E27FC236}">
-                <a16:creationId xmlns:a16="http://schemas.microsoft.com/office/drawing/2014/main" id="{0EAA867D-3F77-45A8-98DD-2A17F72E9F11}"/>
+                <a16:creationId xmlns:a16="http://schemas.microsoft.com/office/drawing/2014/main" id="{42237569-124B-4CDC-AC95-DB274C850FD6}"/>
               </a:ext>
             </a:extLst>
           </p:cNvPr>
@@ -8009,7 +8159,7 @@
           <p:cNvPr id="17" name="">
             <a:extLst xmlns:a="http://schemas.openxmlformats.org/drawingml/2006/main">
               <a:ext uri="{FF2B5EF4-FFF2-40B4-BE49-F238E27FC236}">
-                <a16:creationId xmlns:a16="http://schemas.microsoft.com/office/drawing/2014/main" id="{3502389F-0229-4087-B55A-D98673934C41}"/>
+                <a16:creationId xmlns:a16="http://schemas.microsoft.com/office/drawing/2014/main" id="{822169C9-D410-40B6-9905-2C147FC338F4}"/>
               </a:ext>
             </a:extLst>
           </p:cNvPr>
@@ -8128,7 +8278,7 @@
     </p:spTree>
     <p:extLst>
       <p:ext uri="{BB962C8B-B14F-4D97-AF65-F5344CB8AC3E}">
-        <p14:creationId xmlns:p14="http://schemas.microsoft.com/office/powerpoint/2010/main" val="109166147"/>
+        <p14:creationId xmlns:p14="http://schemas.microsoft.com/office/powerpoint/2010/main" val="766174197"/>
       </p:ext>
     </p:extLst>
   </p:cSld>
@@ -8159,7 +8309,7 @@
           <p:cNvPr id="18" name="">
             <a:extLst xmlns:a="http://schemas.openxmlformats.org/drawingml/2006/main">
               <a:ext uri="{FF2B5EF4-FFF2-40B4-BE49-F238E27FC236}">
-                <a16:creationId xmlns:a16="http://schemas.microsoft.com/office/drawing/2014/main" id="{D5A5B70A-2C60-4899-B462-00E6FB9C929D}"/>
+                <a16:creationId xmlns:a16="http://schemas.microsoft.com/office/drawing/2014/main" id="{A010C8CB-A86E-4EF8-B741-4AB5EC43A897}"/>
               </a:ext>
             </a:extLst>
           </p:cNvPr>
@@ -8280,7 +8430,7 @@
           <p:cNvPr id="2" name="">
             <a:extLst xmlns:a="http://schemas.openxmlformats.org/drawingml/2006/main">
               <a:ext uri="{FF2B5EF4-FFF2-40B4-BE49-F238E27FC236}">
-                <a16:creationId xmlns:a16="http://schemas.microsoft.com/office/drawing/2014/main" id="{D5293DC5-CC5C-42E5-BD7F-FC438BCA3DC4}"/>
+                <a16:creationId xmlns:a16="http://schemas.microsoft.com/office/drawing/2014/main" id="{8AA94AF5-BA84-4165-9EC6-B557FCBA72E5}"/>
               </a:ext>
             </a:extLst>
           </p:cNvPr>
@@ -8311,7 +8461,7 @@
           <p:cNvPr id="3" name="">
             <a:extLst xmlns:a="http://schemas.openxmlformats.org/drawingml/2006/main">
               <a:ext uri="{FF2B5EF4-FFF2-40B4-BE49-F238E27FC236}">
-                <a16:creationId xmlns:a16="http://schemas.microsoft.com/office/drawing/2014/main" id="{3166B9AA-0537-4F40-ABC3-BAD8852927BA}"/>
+                <a16:creationId xmlns:a16="http://schemas.microsoft.com/office/drawing/2014/main" id="{03FE1D7F-7A09-44F5-9804-53EAE744A3D9}"/>
               </a:ext>
             </a:extLst>
           </p:cNvPr>
@@ -8432,7 +8582,7 @@
           <p:cNvPr id="4" name="">
             <a:extLst xmlns:a="http://schemas.openxmlformats.org/drawingml/2006/main">
               <a:ext uri="{FF2B5EF4-FFF2-40B4-BE49-F238E27FC236}">
-                <a16:creationId xmlns:a16="http://schemas.microsoft.com/office/drawing/2014/main" id="{88C2CECE-51FA-4D29-B273-FC2C55BD2923}"/>
+                <a16:creationId xmlns:a16="http://schemas.microsoft.com/office/drawing/2014/main" id="{52E8E7A9-2F5E-4F2A-9C41-A9AFFC3D1706}"/>
               </a:ext>
             </a:extLst>
           </p:cNvPr>
@@ -8465,7 +8615,7 @@
           <p:cNvPr id="5" name="">
             <a:extLst xmlns:a="http://schemas.openxmlformats.org/drawingml/2006/main">
               <a:ext uri="{FF2B5EF4-FFF2-40B4-BE49-F238E27FC236}">
-                <a16:creationId xmlns:a16="http://schemas.microsoft.com/office/drawing/2014/main" id="{76A57ECB-00D8-4AA7-BD2A-BEB021C99A3C}"/>
+                <a16:creationId xmlns:a16="http://schemas.microsoft.com/office/drawing/2014/main" id="{C5174B15-DADD-4A41-BBB4-88D12D9185D4}"/>
               </a:ext>
             </a:extLst>
           </p:cNvPr>
@@ -8496,7 +8646,7 @@
           <p:cNvPr id="6" name="">
             <a:extLst xmlns:a="http://schemas.openxmlformats.org/drawingml/2006/main">
               <a:ext uri="{FF2B5EF4-FFF2-40B4-BE49-F238E27FC236}">
-                <a16:creationId xmlns:a16="http://schemas.microsoft.com/office/drawing/2014/main" id="{CB199400-53DC-4D26-83BC-ECE328595D3A}"/>
+                <a16:creationId xmlns:a16="http://schemas.microsoft.com/office/drawing/2014/main" id="{CDF580FB-7FCF-447B-869F-DAC2F6F3B4EF}"/>
               </a:ext>
             </a:extLst>
           </p:cNvPr>
@@ -8617,7 +8767,7 @@
           <p:cNvPr id="7" name="">
             <a:extLst xmlns:a="http://schemas.openxmlformats.org/drawingml/2006/main">
               <a:ext uri="{FF2B5EF4-FFF2-40B4-BE49-F238E27FC236}">
-                <a16:creationId xmlns:a16="http://schemas.microsoft.com/office/drawing/2014/main" id="{A571B1C0-F0E4-438C-B709-9C68E4014279}"/>
+                <a16:creationId xmlns:a16="http://schemas.microsoft.com/office/drawing/2014/main" id="{3DDDF9B3-8457-4010-BA18-F02540A4640A}"/>
               </a:ext>
             </a:extLst>
           </p:cNvPr>
@@ -8782,7 +8932,7 @@
           <p:cNvPr id="8" name="">
             <a:extLst xmlns:a="http://schemas.openxmlformats.org/drawingml/2006/main">
               <a:ext uri="{FF2B5EF4-FFF2-40B4-BE49-F238E27FC236}">
-                <a16:creationId xmlns:a16="http://schemas.microsoft.com/office/drawing/2014/main" id="{B83C2FD1-CE23-4D8F-B711-A0210408757B}"/>
+                <a16:creationId xmlns:a16="http://schemas.microsoft.com/office/drawing/2014/main" id="{F0F5B032-D10A-49B4-BCD4-9175E8596390}"/>
               </a:ext>
             </a:extLst>
           </p:cNvPr>
@@ -8815,7 +8965,7 @@
           <p:cNvPr id="9" name="">
             <a:extLst xmlns:a="http://schemas.openxmlformats.org/drawingml/2006/main">
               <a:ext uri="{FF2B5EF4-FFF2-40B4-BE49-F238E27FC236}">
-                <a16:creationId xmlns:a16="http://schemas.microsoft.com/office/drawing/2014/main" id="{B4F77C4B-234C-4C2F-9049-FBF27E43BDE8}"/>
+                <a16:creationId xmlns:a16="http://schemas.microsoft.com/office/drawing/2014/main" id="{97F8F8CA-D0F7-4DB6-B974-1BB9F98FD1F8}"/>
               </a:ext>
             </a:extLst>
           </p:cNvPr>
@@ -8846,7 +8996,7 @@
           <p:cNvPr id="10" name="">
             <a:extLst xmlns:a="http://schemas.openxmlformats.org/drawingml/2006/main">
               <a:ext uri="{FF2B5EF4-FFF2-40B4-BE49-F238E27FC236}">
-                <a16:creationId xmlns:a16="http://schemas.microsoft.com/office/drawing/2014/main" id="{67181512-1053-4EA6-B5BC-B63DC35464D4}"/>
+                <a16:creationId xmlns:a16="http://schemas.microsoft.com/office/drawing/2014/main" id="{A8168A96-CC3F-45BC-927F-3C5442DEB92E}"/>
               </a:ext>
             </a:extLst>
           </p:cNvPr>
@@ -8967,7 +9117,7 @@
           <p:cNvPr id="11" name="">
             <a:extLst xmlns:a="http://schemas.openxmlformats.org/drawingml/2006/main">
               <a:ext uri="{FF2B5EF4-FFF2-40B4-BE49-F238E27FC236}">
-                <a16:creationId xmlns:a16="http://schemas.microsoft.com/office/drawing/2014/main" id="{2F085331-5965-49B5-AA1F-7824315B7094}"/>
+                <a16:creationId xmlns:a16="http://schemas.microsoft.com/office/drawing/2014/main" id="{05207FF1-3634-47A5-9FE5-BEDE7DDE8D60}"/>
               </a:ext>
             </a:extLst>
           </p:cNvPr>
@@ -9132,7 +9282,7 @@
           <p:cNvPr id="12" name="">
             <a:extLst xmlns:a="http://schemas.openxmlformats.org/drawingml/2006/main">
               <a:ext uri="{FF2B5EF4-FFF2-40B4-BE49-F238E27FC236}">
-                <a16:creationId xmlns:a16="http://schemas.microsoft.com/office/drawing/2014/main" id="{F7C8E571-EC29-47C3-BC4D-8172634C03C7}"/>
+                <a16:creationId xmlns:a16="http://schemas.microsoft.com/office/drawing/2014/main" id="{979C74C5-2368-4AD9-BAB5-3D0B2B1BF06B}"/>
               </a:ext>
             </a:extLst>
           </p:cNvPr>
@@ -9165,7 +9315,7 @@
           <p:cNvPr id="13" name="">
             <a:extLst xmlns:a="http://schemas.openxmlformats.org/drawingml/2006/main">
               <a:ext uri="{FF2B5EF4-FFF2-40B4-BE49-F238E27FC236}">
-                <a16:creationId xmlns:a16="http://schemas.microsoft.com/office/drawing/2014/main" id="{0C4749A2-2C6B-48A7-998B-B53599F7A50F}"/>
+                <a16:creationId xmlns:a16="http://schemas.microsoft.com/office/drawing/2014/main" id="{DB6C24FB-D0D5-40A6-B0B8-A3DF20378A7C}"/>
               </a:ext>
             </a:extLst>
           </p:cNvPr>
@@ -9196,7 +9346,7 @@
           <p:cNvPr id="14" name="">
             <a:extLst xmlns:a="http://schemas.openxmlformats.org/drawingml/2006/main">
               <a:ext uri="{FF2B5EF4-FFF2-40B4-BE49-F238E27FC236}">
-                <a16:creationId xmlns:a16="http://schemas.microsoft.com/office/drawing/2014/main" id="{A754925E-DBC0-4C3D-9BA5-FDDAAC1D77BC}"/>
+                <a16:creationId xmlns:a16="http://schemas.microsoft.com/office/drawing/2014/main" id="{DB40768F-F67F-49F5-9928-2681C4F94118}"/>
               </a:ext>
             </a:extLst>
           </p:cNvPr>
@@ -9317,7 +9467,7 @@
           <p:cNvPr id="15" name="">
             <a:extLst xmlns:a="http://schemas.openxmlformats.org/drawingml/2006/main">
               <a:ext uri="{FF2B5EF4-FFF2-40B4-BE49-F238E27FC236}">
-                <a16:creationId xmlns:a16="http://schemas.microsoft.com/office/drawing/2014/main" id="{3DAF0780-86FE-486A-B996-DA982ECEDF49}"/>
+                <a16:creationId xmlns:a16="http://schemas.microsoft.com/office/drawing/2014/main" id="{26D94DC3-9959-4CCF-A75C-71025AC91BB4}"/>
               </a:ext>
             </a:extLst>
           </p:cNvPr>
@@ -9482,7 +9632,7 @@
           <p:cNvPr id="16" name="">
             <a:extLst xmlns:a="http://schemas.openxmlformats.org/drawingml/2006/main">
               <a:ext uri="{FF2B5EF4-FFF2-40B4-BE49-F238E27FC236}">
-                <a16:creationId xmlns:a16="http://schemas.microsoft.com/office/drawing/2014/main" id="{998F4077-2D60-42FC-8A3D-1D84F7849796}"/>
+                <a16:creationId xmlns:a16="http://schemas.microsoft.com/office/drawing/2014/main" id="{D9A6BD29-EE79-43E0-BB10-4D307DF41E98}"/>
               </a:ext>
             </a:extLst>
           </p:cNvPr>
@@ -9603,7 +9753,7 @@
           <p:cNvPr id="17" name="">
             <a:extLst xmlns:a="http://schemas.openxmlformats.org/drawingml/2006/main">
               <a:ext uri="{FF2B5EF4-FFF2-40B4-BE49-F238E27FC236}">
-                <a16:creationId xmlns:a16="http://schemas.microsoft.com/office/drawing/2014/main" id="{0C4E9AF5-4010-48D7-8078-586447DC4667}"/>
+                <a16:creationId xmlns:a16="http://schemas.microsoft.com/office/drawing/2014/main" id="{0E185251-FB25-4930-8B5A-6CF282789D20}"/>
               </a:ext>
             </a:extLst>
           </p:cNvPr>
@@ -9722,7 +9872,7 @@
     </p:spTree>
     <p:extLst>
       <p:ext uri="{BB962C8B-B14F-4D97-AF65-F5344CB8AC3E}">
-        <p14:creationId xmlns:p14="http://schemas.microsoft.com/office/powerpoint/2010/main" val="215577654"/>
+        <p14:creationId xmlns:p14="http://schemas.microsoft.com/office/powerpoint/2010/main" val="1848700989"/>
       </p:ext>
     </p:extLst>
   </p:cSld>
@@ -9753,7 +9903,7 @@
           <p:cNvPr id="12" name="">
             <a:extLst xmlns:a="http://schemas.openxmlformats.org/drawingml/2006/main">
               <a:ext uri="{FF2B5EF4-FFF2-40B4-BE49-F238E27FC236}">
-                <a16:creationId xmlns:a16="http://schemas.microsoft.com/office/drawing/2014/main" id="{28F89DCA-37F8-4B3C-A515-764A26907857}"/>
+                <a16:creationId xmlns:a16="http://schemas.microsoft.com/office/drawing/2014/main" id="{7803101C-E5BE-49AC-AD26-3FCF2A2E8032}"/>
               </a:ext>
             </a:extLst>
           </p:cNvPr>
@@ -9874,7 +10024,7 @@
           <p:cNvPr id="2" name="">
             <a:extLst xmlns:a="http://schemas.openxmlformats.org/drawingml/2006/main">
               <a:ext uri="{FF2B5EF4-FFF2-40B4-BE49-F238E27FC236}">
-                <a16:creationId xmlns:a16="http://schemas.microsoft.com/office/drawing/2014/main" id="{32CEC618-D8A1-4C6B-8D34-B99BD06598C0}"/>
+                <a16:creationId xmlns:a16="http://schemas.microsoft.com/office/drawing/2014/main" id="{012834B7-A006-469B-BA11-471BF8DAE4BE}"/>
               </a:ext>
             </a:extLst>
           </p:cNvPr>
@@ -9995,7 +10145,7 @@
           <p:cNvPr id="3" name="">
             <a:extLst xmlns:a="http://schemas.openxmlformats.org/drawingml/2006/main">
               <a:ext uri="{FF2B5EF4-FFF2-40B4-BE49-F238E27FC236}">
-                <a16:creationId xmlns:a16="http://schemas.microsoft.com/office/drawing/2014/main" id="{C76A1D5A-1E9D-46F4-8A84-203217818E1D}"/>
+                <a16:creationId xmlns:a16="http://schemas.microsoft.com/office/drawing/2014/main" id="{52840ED1-A756-4D31-B77A-34957F2774CA}"/>
               </a:ext>
             </a:extLst>
           </p:cNvPr>
@@ -10150,7 +10300,7 @@
           <p:cNvPr id="4" name="">
             <a:extLst xmlns:a="http://schemas.openxmlformats.org/drawingml/2006/main">
               <a:ext uri="{FF2B5EF4-FFF2-40B4-BE49-F238E27FC236}">
-                <a16:creationId xmlns:a16="http://schemas.microsoft.com/office/drawing/2014/main" id="{B1999D24-E9A0-43FB-8DA1-A6E089D41082}"/>
+                <a16:creationId xmlns:a16="http://schemas.microsoft.com/office/drawing/2014/main" id="{7BCE491D-0552-408F-8B84-5BD1BB33D1C9}"/>
               </a:ext>
             </a:extLst>
           </p:cNvPr>
@@ -10183,7 +10333,7 @@
           <p:cNvPr id="5" name="">
             <a:extLst xmlns:a="http://schemas.openxmlformats.org/drawingml/2006/main">
               <a:ext uri="{FF2B5EF4-FFF2-40B4-BE49-F238E27FC236}">
-                <a16:creationId xmlns:a16="http://schemas.microsoft.com/office/drawing/2014/main" id="{0CD23469-93E2-4B4F-8299-173A4E2065D1}"/>
+                <a16:creationId xmlns:a16="http://schemas.microsoft.com/office/drawing/2014/main" id="{3A6DB03C-B127-48D7-BA8E-D123E73393B0}"/>
               </a:ext>
             </a:extLst>
           </p:cNvPr>
@@ -10304,7 +10454,7 @@
           <p:cNvPr id="6" name="">
             <a:extLst xmlns:a="http://schemas.openxmlformats.org/drawingml/2006/main">
               <a:ext uri="{FF2B5EF4-FFF2-40B4-BE49-F238E27FC236}">
-                <a16:creationId xmlns:a16="http://schemas.microsoft.com/office/drawing/2014/main" id="{8C418F16-0BB9-4E3C-B54E-4D4E2004584D}"/>
+                <a16:creationId xmlns:a16="http://schemas.microsoft.com/office/drawing/2014/main" id="{C1538D48-13F3-49D4-AED3-1FCE6752A51A}"/>
               </a:ext>
             </a:extLst>
           </p:cNvPr>
@@ -10425,7 +10575,7 @@
           <p:cNvPr id="7" name="">
             <a:extLst xmlns:a="http://schemas.openxmlformats.org/drawingml/2006/main">
               <a:ext uri="{FF2B5EF4-FFF2-40B4-BE49-F238E27FC236}">
-                <a16:creationId xmlns:a16="http://schemas.microsoft.com/office/drawing/2014/main" id="{7D8F1B2D-0ACC-4006-A43A-2BF57CBEACA3}"/>
+                <a16:creationId xmlns:a16="http://schemas.microsoft.com/office/drawing/2014/main" id="{3A8B38CE-1C5D-497C-8382-2A5B50C8D759}"/>
               </a:ext>
             </a:extLst>
           </p:cNvPr>
@@ -10435,7 +10585,7 @@
           <p:nvPr/>
         </p:nvPicPr>
         <p:blipFill>
-          <a:blip xmlns:r="http://schemas.openxmlformats.org/officeDocument/2006/relationships" xmlns:a="http://schemas.openxmlformats.org/drawingml/2006/main" r:embed="Rf24266a28d4a43e4"/>
+          <a:blip xmlns:r="http://schemas.openxmlformats.org/officeDocument/2006/relationships" xmlns:a="http://schemas.openxmlformats.org/drawingml/2006/main" r:embed="Rbb69bb1b12dd4bd0"/>
           <a:stretch xmlns:a="http://schemas.openxmlformats.org/drawingml/2006/main"/>
         </p:blipFill>
         <p:spPr>
@@ -10453,7 +10603,7 @@
           <p:cNvPr id="8" name="">
             <a:extLst xmlns:a="http://schemas.openxmlformats.org/drawingml/2006/main">
               <a:ext uri="{FF2B5EF4-FFF2-40B4-BE49-F238E27FC236}">
-                <a16:creationId xmlns:a16="http://schemas.microsoft.com/office/drawing/2014/main" id="{6FF14663-8E74-4A5B-B8AC-32F7CC35CABF}"/>
+                <a16:creationId xmlns:a16="http://schemas.microsoft.com/office/drawing/2014/main" id="{F62DDB72-2B01-4C64-AACA-58914A169221}"/>
               </a:ext>
             </a:extLst>
           </p:cNvPr>
@@ -10574,7 +10724,7 @@
           <p:cNvPr id="9" name="">
             <a:extLst xmlns:a="http://schemas.openxmlformats.org/drawingml/2006/main">
               <a:ext uri="{FF2B5EF4-FFF2-40B4-BE49-F238E27FC236}">
-                <a16:creationId xmlns:a16="http://schemas.microsoft.com/office/drawing/2014/main" id="{66D80E4A-D174-4D20-97EE-8838D582DD79}"/>
+                <a16:creationId xmlns:a16="http://schemas.microsoft.com/office/drawing/2014/main" id="{441F9769-E4B6-4166-814C-B5F0DEC17698}"/>
               </a:ext>
             </a:extLst>
           </p:cNvPr>
@@ -10605,7 +10755,7 @@
           <p:cNvPr id="10" name="">
             <a:extLst xmlns:a="http://schemas.openxmlformats.org/drawingml/2006/main">
               <a:ext uri="{FF2B5EF4-FFF2-40B4-BE49-F238E27FC236}">
-                <a16:creationId xmlns:a16="http://schemas.microsoft.com/office/drawing/2014/main" id="{47E293F8-73A6-41FE-A43C-DC2232ABF77E}"/>
+                <a16:creationId xmlns:a16="http://schemas.microsoft.com/office/drawing/2014/main" id="{22B9321A-60DC-407A-B9C3-AC0A01378DA5}"/>
               </a:ext>
             </a:extLst>
           </p:cNvPr>
@@ -10726,7 +10876,7 @@
           <p:cNvPr id="11" name="">
             <a:extLst xmlns:a="http://schemas.openxmlformats.org/drawingml/2006/main">
               <a:ext uri="{FF2B5EF4-FFF2-40B4-BE49-F238E27FC236}">
-                <a16:creationId xmlns:a16="http://schemas.microsoft.com/office/drawing/2014/main" id="{BC887C84-1A88-4909-8D46-0E9C318B57DF}"/>
+                <a16:creationId xmlns:a16="http://schemas.microsoft.com/office/drawing/2014/main" id="{1C444CBA-4160-42CB-83F2-F7D04198434C}"/>
               </a:ext>
             </a:extLst>
           </p:cNvPr>
@@ -10845,7 +10995,7 @@
     </p:spTree>
     <p:extLst>
       <p:ext uri="{BB962C8B-B14F-4D97-AF65-F5344CB8AC3E}">
-        <p14:creationId xmlns:p14="http://schemas.microsoft.com/office/powerpoint/2010/main" val="1126688658"/>
+        <p14:creationId xmlns:p14="http://schemas.microsoft.com/office/powerpoint/2010/main" val="596239807"/>
       </p:ext>
     </p:extLst>
   </p:cSld>
@@ -10876,7 +11026,7 @@
           <p:cNvPr id="9" name="">
             <a:extLst xmlns:a="http://schemas.openxmlformats.org/drawingml/2006/main">
               <a:ext uri="{FF2B5EF4-FFF2-40B4-BE49-F238E27FC236}">
-                <a16:creationId xmlns:a16="http://schemas.microsoft.com/office/drawing/2014/main" id="{F417E965-6232-4576-99C1-5019B480241F}"/>
+                <a16:creationId xmlns:a16="http://schemas.microsoft.com/office/drawing/2014/main" id="{18ACB07F-756F-42F5-AE3A-374BC9323856}"/>
               </a:ext>
             </a:extLst>
           </p:cNvPr>
@@ -10997,7 +11147,7 @@
           <p:cNvPr id="2" name="">
             <a:extLst xmlns:a="http://schemas.openxmlformats.org/drawingml/2006/main">
               <a:ext uri="{FF2B5EF4-FFF2-40B4-BE49-F238E27FC236}">
-                <a16:creationId xmlns:a16="http://schemas.microsoft.com/office/drawing/2014/main" id="{BA06A674-2CEA-4F10-B3CA-EBF4319F8869}"/>
+                <a16:creationId xmlns:a16="http://schemas.microsoft.com/office/drawing/2014/main" id="{4A134008-05C0-4D83-9985-FC8190FCE4BD}"/>
               </a:ext>
             </a:extLst>
           </p:cNvPr>
@@ -11028,7 +11178,7 @@
           <p:cNvPr id="3" name="">
             <a:extLst xmlns:a="http://schemas.openxmlformats.org/drawingml/2006/main">
               <a:ext uri="{FF2B5EF4-FFF2-40B4-BE49-F238E27FC236}">
-                <a16:creationId xmlns:a16="http://schemas.microsoft.com/office/drawing/2014/main" id="{021F9F6A-B102-4DC8-B79C-D3E0977CF80B}"/>
+                <a16:creationId xmlns:a16="http://schemas.microsoft.com/office/drawing/2014/main" id="{46BFD786-1926-486F-AF1A-9C54749DFD8C}"/>
               </a:ext>
             </a:extLst>
           </p:cNvPr>
@@ -11149,7 +11299,7 @@
           <p:cNvPr id="4" name="">
             <a:extLst xmlns:a="http://schemas.openxmlformats.org/drawingml/2006/main">
               <a:ext uri="{FF2B5EF4-FFF2-40B4-BE49-F238E27FC236}">
-                <a16:creationId xmlns:a16="http://schemas.microsoft.com/office/drawing/2014/main" id="{2FE6E547-316B-488E-9C50-496757979A6B}"/>
+                <a16:creationId xmlns:a16="http://schemas.microsoft.com/office/drawing/2014/main" id="{0DD9356E-C561-472D-95CE-D8710B9A8B33}"/>
               </a:ext>
             </a:extLst>
           </p:cNvPr>
@@ -11270,7 +11420,7 @@
           <p:cNvPr id="5" name="">
             <a:extLst xmlns:a="http://schemas.openxmlformats.org/drawingml/2006/main">
               <a:ext uri="{FF2B5EF4-FFF2-40B4-BE49-F238E27FC236}">
-                <a16:creationId xmlns:a16="http://schemas.microsoft.com/office/drawing/2014/main" id="{01DADBA0-1797-43BB-86E2-493BD7C65B90}"/>
+                <a16:creationId xmlns:a16="http://schemas.microsoft.com/office/drawing/2014/main" id="{E602E1BE-8077-4167-8BF7-FB27E57A5714}"/>
               </a:ext>
             </a:extLst>
           </p:cNvPr>
@@ -12150,7 +12300,7 @@
           <p:cNvPr id="6" name="">
             <a:extLst xmlns:a="http://schemas.openxmlformats.org/drawingml/2006/main">
               <a:ext uri="{FF2B5EF4-FFF2-40B4-BE49-F238E27FC236}">
-                <a16:creationId xmlns:a16="http://schemas.microsoft.com/office/drawing/2014/main" id="{53520DE6-F324-4E75-BC49-96925847924D}"/>
+                <a16:creationId xmlns:a16="http://schemas.microsoft.com/office/drawing/2014/main" id="{C48E0762-EA57-4A31-9025-64A57D1181C2}"/>
               </a:ext>
             </a:extLst>
           </p:cNvPr>
@@ -12271,7 +12421,7 @@
           <p:cNvPr id="7" name="">
             <a:extLst xmlns:a="http://schemas.openxmlformats.org/drawingml/2006/main">
               <a:ext uri="{FF2B5EF4-FFF2-40B4-BE49-F238E27FC236}">
-                <a16:creationId xmlns:a16="http://schemas.microsoft.com/office/drawing/2014/main" id="{CCD5B91F-EFFE-45A8-B362-CA1DB5DCE085}"/>
+                <a16:creationId xmlns:a16="http://schemas.microsoft.com/office/drawing/2014/main" id="{69E8E8F5-1D87-4B99-A405-21BF8041EBAF}"/>
               </a:ext>
             </a:extLst>
           </p:cNvPr>
@@ -12392,7 +12542,7 @@
           <p:cNvPr id="8" name="">
             <a:extLst xmlns:a="http://schemas.openxmlformats.org/drawingml/2006/main">
               <a:ext uri="{FF2B5EF4-FFF2-40B4-BE49-F238E27FC236}">
-                <a16:creationId xmlns:a16="http://schemas.microsoft.com/office/drawing/2014/main" id="{45283137-D4A8-498D-81CC-B18E2E5D8082}"/>
+                <a16:creationId xmlns:a16="http://schemas.microsoft.com/office/drawing/2014/main" id="{6B677D82-4216-40A4-A390-8CE7ABE38AA4}"/>
               </a:ext>
             </a:extLst>
           </p:cNvPr>
@@ -12511,7 +12661,7 @@
     </p:spTree>
     <p:extLst>
       <p:ext uri="{BB962C8B-B14F-4D97-AF65-F5344CB8AC3E}">
-        <p14:creationId xmlns:p14="http://schemas.microsoft.com/office/powerpoint/2010/main" val="277716158"/>
+        <p14:creationId xmlns:p14="http://schemas.microsoft.com/office/powerpoint/2010/main" val="1936088956"/>
       </p:ext>
     </p:extLst>
   </p:cSld>
@@ -12542,7 +12692,7 @@
           <p:cNvPr id="14" name="">
             <a:extLst xmlns:a="http://schemas.openxmlformats.org/drawingml/2006/main">
               <a:ext uri="{FF2B5EF4-FFF2-40B4-BE49-F238E27FC236}">
-                <a16:creationId xmlns:a16="http://schemas.microsoft.com/office/drawing/2014/main" id="{51C8267B-B44B-4F77-AF79-0171CE0D861A}"/>
+                <a16:creationId xmlns:a16="http://schemas.microsoft.com/office/drawing/2014/main" id="{0BF04E74-6948-48AA-ABF4-E42E478C977C}"/>
               </a:ext>
             </a:extLst>
           </p:cNvPr>
@@ -12552,7 +12702,7 @@
           <p:nvPr/>
         </p:nvPicPr>
         <p:blipFill>
-          <a:blip xmlns:r="http://schemas.openxmlformats.org/officeDocument/2006/relationships" xmlns:a="http://schemas.openxmlformats.org/drawingml/2006/main" r:embed="Rd7f269ba502c42b0"/>
+          <a:blip xmlns:r="http://schemas.openxmlformats.org/officeDocument/2006/relationships" xmlns:a="http://schemas.openxmlformats.org/drawingml/2006/main" r:embed="Re2d623fc4a5a4a4e"/>
           <a:stretch xmlns:a="http://schemas.openxmlformats.org/drawingml/2006/main"/>
         </p:blipFill>
         <p:spPr>
@@ -12570,7 +12720,7 @@
           <p:cNvPr id="2" name="">
             <a:extLst xmlns:a="http://schemas.openxmlformats.org/drawingml/2006/main">
               <a:ext uri="{FF2B5EF4-FFF2-40B4-BE49-F238E27FC236}">
-                <a16:creationId xmlns:a16="http://schemas.microsoft.com/office/drawing/2014/main" id="{773850A4-E336-4F9C-BC42-15FF6C343845}"/>
+                <a16:creationId xmlns:a16="http://schemas.microsoft.com/office/drawing/2014/main" id="{4FA72F79-9554-47BC-9D6C-B40929136F5D}"/>
               </a:ext>
             </a:extLst>
           </p:cNvPr>
@@ -12691,7 +12841,7 @@
           <p:cNvPr id="3" name="">
             <a:extLst xmlns:a="http://schemas.openxmlformats.org/drawingml/2006/main">
               <a:ext uri="{FF2B5EF4-FFF2-40B4-BE49-F238E27FC236}">
-                <a16:creationId xmlns:a16="http://schemas.microsoft.com/office/drawing/2014/main" id="{7809DE16-2075-4448-B2D6-FEEF3DBA768C}"/>
+                <a16:creationId xmlns:a16="http://schemas.microsoft.com/office/drawing/2014/main" id="{1119F408-D622-424D-A913-A0DE674B4239}"/>
               </a:ext>
             </a:extLst>
           </p:cNvPr>
@@ -12722,7 +12872,7 @@
           <p:cNvPr id="4" name="">
             <a:extLst xmlns:a="http://schemas.openxmlformats.org/drawingml/2006/main">
               <a:ext uri="{FF2B5EF4-FFF2-40B4-BE49-F238E27FC236}">
-                <a16:creationId xmlns:a16="http://schemas.microsoft.com/office/drawing/2014/main" id="{F51F9447-47AA-4B03-92BD-DA802EADE373}"/>
+                <a16:creationId xmlns:a16="http://schemas.microsoft.com/office/drawing/2014/main" id="{03B69401-71AC-478F-9ABD-08AAA2544DD1}"/>
               </a:ext>
             </a:extLst>
           </p:cNvPr>
@@ -12843,7 +12993,7 @@
           <p:cNvPr id="5" name="">
             <a:extLst xmlns:a="http://schemas.openxmlformats.org/drawingml/2006/main">
               <a:ext uri="{FF2B5EF4-FFF2-40B4-BE49-F238E27FC236}">
-                <a16:creationId xmlns:a16="http://schemas.microsoft.com/office/drawing/2014/main" id="{8950F965-6DAF-4958-B9A2-AF141B880238}"/>
+                <a16:creationId xmlns:a16="http://schemas.microsoft.com/office/drawing/2014/main" id="{76EABB3F-B6C9-48B8-961C-79A5B8F62C6C}"/>
               </a:ext>
             </a:extLst>
           </p:cNvPr>
@@ -12964,7 +13114,7 @@
           <p:cNvPr id="6" name="">
             <a:extLst xmlns:a="http://schemas.openxmlformats.org/drawingml/2006/main">
               <a:ext uri="{FF2B5EF4-FFF2-40B4-BE49-F238E27FC236}">
-                <a16:creationId xmlns:a16="http://schemas.microsoft.com/office/drawing/2014/main" id="{D91CBB6B-7A13-4282-B704-214CD9ACA9B4}"/>
+                <a16:creationId xmlns:a16="http://schemas.microsoft.com/office/drawing/2014/main" id="{8C816BED-470B-4561-B31B-3BFE41AC4079}"/>
               </a:ext>
             </a:extLst>
           </p:cNvPr>
@@ -13085,7 +13235,7 @@
           <p:cNvPr id="7" name="">
             <a:extLst xmlns:a="http://schemas.openxmlformats.org/drawingml/2006/main">
               <a:ext uri="{FF2B5EF4-FFF2-40B4-BE49-F238E27FC236}">
-                <a16:creationId xmlns:a16="http://schemas.microsoft.com/office/drawing/2014/main" id="{234BB375-EA33-4FCE-B774-39E8CDD8127A}"/>
+                <a16:creationId xmlns:a16="http://schemas.microsoft.com/office/drawing/2014/main" id="{5F52244B-0501-40D1-8D72-8F7EF5E42F5F}"/>
               </a:ext>
             </a:extLst>
           </p:cNvPr>
@@ -13206,7 +13356,7 @@
           <p:cNvPr id="8" name="">
             <a:extLst xmlns:a="http://schemas.openxmlformats.org/drawingml/2006/main">
               <a:ext uri="{FF2B5EF4-FFF2-40B4-BE49-F238E27FC236}">
-                <a16:creationId xmlns:a16="http://schemas.microsoft.com/office/drawing/2014/main" id="{2D304DFC-0122-44A3-9FA1-772EAE20D367}"/>
+                <a16:creationId xmlns:a16="http://schemas.microsoft.com/office/drawing/2014/main" id="{5E669A1C-7F74-4895-9F3E-45913DA13748}"/>
               </a:ext>
             </a:extLst>
           </p:cNvPr>
@@ -13327,7 +13477,7 @@
           <p:cNvPr id="9" name="">
             <a:extLst xmlns:a="http://schemas.openxmlformats.org/drawingml/2006/main">
               <a:ext uri="{FF2B5EF4-FFF2-40B4-BE49-F238E27FC236}">
-                <a16:creationId xmlns:a16="http://schemas.microsoft.com/office/drawing/2014/main" id="{7192BD94-C5FC-4EA0-B93F-C87E1292A3B8}"/>
+                <a16:creationId xmlns:a16="http://schemas.microsoft.com/office/drawing/2014/main" id="{5D64690C-59A1-4C99-B7C6-E2C43EAEDB9C}"/>
               </a:ext>
             </a:extLst>
           </p:cNvPr>
@@ -13448,7 +13598,7 @@
           <p:cNvPr id="10" name="">
             <a:extLst xmlns:a="http://schemas.openxmlformats.org/drawingml/2006/main">
               <a:ext uri="{FF2B5EF4-FFF2-40B4-BE49-F238E27FC236}">
-                <a16:creationId xmlns:a16="http://schemas.microsoft.com/office/drawing/2014/main" id="{F7C51AAF-9DE1-4040-9AAC-5B87B19BFBCD}"/>
+                <a16:creationId xmlns:a16="http://schemas.microsoft.com/office/drawing/2014/main" id="{0BBFCC1D-8386-4DF8-B5BA-3E56E71F52E9}"/>
               </a:ext>
             </a:extLst>
           </p:cNvPr>
@@ -13569,7 +13719,7 @@
           <p:cNvPr id="11" name="">
             <a:extLst xmlns:a="http://schemas.openxmlformats.org/drawingml/2006/main">
               <a:ext uri="{FF2B5EF4-FFF2-40B4-BE49-F238E27FC236}">
-                <a16:creationId xmlns:a16="http://schemas.microsoft.com/office/drawing/2014/main" id="{541AF934-B8E4-441C-8971-17A80507CE3A}"/>
+                <a16:creationId xmlns:a16="http://schemas.microsoft.com/office/drawing/2014/main" id="{DD24C522-8B13-475F-A6F6-27C1A35D9B31}"/>
               </a:ext>
             </a:extLst>
           </p:cNvPr>
@@ -13690,7 +13840,7 @@
           <p:cNvPr id="12" name="">
             <a:extLst xmlns:a="http://schemas.openxmlformats.org/drawingml/2006/main">
               <a:ext uri="{FF2B5EF4-FFF2-40B4-BE49-F238E27FC236}">
-                <a16:creationId xmlns:a16="http://schemas.microsoft.com/office/drawing/2014/main" id="{CDC33557-A596-4AB5-9A15-0F53045E05B3}"/>
+                <a16:creationId xmlns:a16="http://schemas.microsoft.com/office/drawing/2014/main" id="{249EFED2-580F-4A92-B18C-6EF7209A91CC}"/>
               </a:ext>
             </a:extLst>
           </p:cNvPr>
@@ -13811,7 +13961,7 @@
           <p:cNvPr id="13" name="">
             <a:extLst xmlns:a="http://schemas.openxmlformats.org/drawingml/2006/main">
               <a:ext uri="{FF2B5EF4-FFF2-40B4-BE49-F238E27FC236}">
-                <a16:creationId xmlns:a16="http://schemas.microsoft.com/office/drawing/2014/main" id="{A7F31D8C-5AE6-4DB3-872C-8EB634FB3326}"/>
+                <a16:creationId xmlns:a16="http://schemas.microsoft.com/office/drawing/2014/main" id="{7372FE00-17F1-4D64-808F-49DFAFA84648}"/>
               </a:ext>
             </a:extLst>
           </p:cNvPr>
@@ -13930,7 +14080,7 @@
     </p:spTree>
     <p:extLst>
       <p:ext uri="{BB962C8B-B14F-4D97-AF65-F5344CB8AC3E}">
-        <p14:creationId xmlns:p14="http://schemas.microsoft.com/office/powerpoint/2010/main" val="1517837842"/>
+        <p14:creationId xmlns:p14="http://schemas.microsoft.com/office/powerpoint/2010/main" val="1508087569"/>
       </p:ext>
     </p:extLst>
   </p:cSld>
@@ -13961,7 +14111,7 @@
           <p:cNvPr id="13" name="">
             <a:extLst xmlns:a="http://schemas.openxmlformats.org/drawingml/2006/main">
               <a:ext uri="{FF2B5EF4-FFF2-40B4-BE49-F238E27FC236}">
-                <a16:creationId xmlns:a16="http://schemas.microsoft.com/office/drawing/2014/main" id="{9E033E92-6366-46AA-BAB0-41472C0B5A77}"/>
+                <a16:creationId xmlns:a16="http://schemas.microsoft.com/office/drawing/2014/main" id="{020BE605-BB7E-4A09-A6C2-F9F2085EF87F}"/>
               </a:ext>
             </a:extLst>
           </p:cNvPr>
@@ -14082,7 +14232,7 @@
           <p:cNvPr id="2" name="">
             <a:extLst xmlns:a="http://schemas.openxmlformats.org/drawingml/2006/main">
               <a:ext uri="{FF2B5EF4-FFF2-40B4-BE49-F238E27FC236}">
-                <a16:creationId xmlns:a16="http://schemas.microsoft.com/office/drawing/2014/main" id="{7A2F0A6D-3919-4608-A01C-D57386FA0673}"/>
+                <a16:creationId xmlns:a16="http://schemas.microsoft.com/office/drawing/2014/main" id="{8C0A4B81-EFD1-45E0-AD85-921D27C6252D}"/>
               </a:ext>
             </a:extLst>
           </p:cNvPr>
@@ -14203,7 +14353,7 @@
           <p:cNvPr id="3" name="">
             <a:extLst xmlns:a="http://schemas.openxmlformats.org/drawingml/2006/main">
               <a:ext uri="{FF2B5EF4-FFF2-40B4-BE49-F238E27FC236}">
-                <a16:creationId xmlns:a16="http://schemas.microsoft.com/office/drawing/2014/main" id="{84E9D2C7-838A-4312-AF26-33E055CF4E09}"/>
+                <a16:creationId xmlns:a16="http://schemas.microsoft.com/office/drawing/2014/main" id="{F194B4CA-83F1-409A-996A-7F379EF4EB0F}"/>
               </a:ext>
             </a:extLst>
           </p:cNvPr>
@@ -14324,7 +14474,7 @@
           <p:cNvPr id="4" name="">
             <a:extLst xmlns:a="http://schemas.openxmlformats.org/drawingml/2006/main">
               <a:ext uri="{FF2B5EF4-FFF2-40B4-BE49-F238E27FC236}">
-                <a16:creationId xmlns:a16="http://schemas.microsoft.com/office/drawing/2014/main" id="{27F338A0-BD7D-465F-8CF2-2D60031AF25E}"/>
+                <a16:creationId xmlns:a16="http://schemas.microsoft.com/office/drawing/2014/main" id="{077DDDFA-466D-45CB-B1D8-93E6B3CE702C}"/>
               </a:ext>
             </a:extLst>
           </p:cNvPr>
@@ -14445,7 +14595,7 @@
           <p:cNvPr id="5" name="">
             <a:extLst xmlns:a="http://schemas.openxmlformats.org/drawingml/2006/main">
               <a:ext uri="{FF2B5EF4-FFF2-40B4-BE49-F238E27FC236}">
-                <a16:creationId xmlns:a16="http://schemas.microsoft.com/office/drawing/2014/main" id="{480B2105-94BD-490D-B8A6-403DF7C7D2DE}"/>
+                <a16:creationId xmlns:a16="http://schemas.microsoft.com/office/drawing/2014/main" id="{9091E5CF-79B4-4EBF-8A6D-536A92EF6455}"/>
               </a:ext>
             </a:extLst>
           </p:cNvPr>
@@ -14566,7 +14716,7 @@
           <p:cNvPr id="6" name="">
             <a:extLst xmlns:a="http://schemas.openxmlformats.org/drawingml/2006/main">
               <a:ext uri="{FF2B5EF4-FFF2-40B4-BE49-F238E27FC236}">
-                <a16:creationId xmlns:a16="http://schemas.microsoft.com/office/drawing/2014/main" id="{6D9B350E-D34E-4B34-875A-CD3B00ACB6F9}"/>
+                <a16:creationId xmlns:a16="http://schemas.microsoft.com/office/drawing/2014/main" id="{DD7BF5CF-A430-44A3-9D2A-CF65B08EAC3F}"/>
               </a:ext>
             </a:extLst>
           </p:cNvPr>
@@ -14687,7 +14837,7 @@
           <p:cNvPr id="7" name="">
             <a:extLst xmlns:a="http://schemas.openxmlformats.org/drawingml/2006/main">
               <a:ext uri="{FF2B5EF4-FFF2-40B4-BE49-F238E27FC236}">
-                <a16:creationId xmlns:a16="http://schemas.microsoft.com/office/drawing/2014/main" id="{CB924323-FBF9-41A9-A0BE-88589719EA1C}"/>
+                <a16:creationId xmlns:a16="http://schemas.microsoft.com/office/drawing/2014/main" id="{3A44002C-973D-4BC1-AB12-1110E668FC89}"/>
               </a:ext>
             </a:extLst>
           </p:cNvPr>
@@ -14808,7 +14958,7 @@
           <p:cNvPr id="8" name="">
             <a:extLst xmlns:a="http://schemas.openxmlformats.org/drawingml/2006/main">
               <a:ext uri="{FF2B5EF4-FFF2-40B4-BE49-F238E27FC236}">
-                <a16:creationId xmlns:a16="http://schemas.microsoft.com/office/drawing/2014/main" id="{DAC18593-F0EF-4C2F-81EB-AD613FDEE088}"/>
+                <a16:creationId xmlns:a16="http://schemas.microsoft.com/office/drawing/2014/main" id="{A3D8CA7A-C8CB-42DB-984C-6425A89C61DD}"/>
               </a:ext>
             </a:extLst>
           </p:cNvPr>
@@ -14818,7 +14968,7 @@
           <p:nvPr/>
         </p:nvPicPr>
         <p:blipFill>
-          <a:blip xmlns:r="http://schemas.openxmlformats.org/officeDocument/2006/relationships" xmlns:a="http://schemas.openxmlformats.org/drawingml/2006/main" r:embed="Rbe65dc9f9fea4d84"/>
+          <a:blip xmlns:r="http://schemas.openxmlformats.org/officeDocument/2006/relationships" xmlns:a="http://schemas.openxmlformats.org/drawingml/2006/main" r:embed="R19c79e209b584122"/>
           <a:stretch xmlns:a="http://schemas.openxmlformats.org/drawingml/2006/main"/>
         </p:blipFill>
         <p:spPr>
@@ -14836,7 +14986,7 @@
           <p:cNvPr id="9" name="">
             <a:extLst xmlns:a="http://schemas.openxmlformats.org/drawingml/2006/main">
               <a:ext uri="{FF2B5EF4-FFF2-40B4-BE49-F238E27FC236}">
-                <a16:creationId xmlns:a16="http://schemas.microsoft.com/office/drawing/2014/main" id="{A5691441-A949-4D3F-BB11-1A496A41DDFA}"/>
+                <a16:creationId xmlns:a16="http://schemas.microsoft.com/office/drawing/2014/main" id="{04166655-2048-425A-8A9B-7558D9B09E53}"/>
               </a:ext>
             </a:extLst>
           </p:cNvPr>
@@ -14957,7 +15107,7 @@
           <p:cNvPr id="10" name="">
             <a:extLst xmlns:a="http://schemas.openxmlformats.org/drawingml/2006/main">
               <a:ext uri="{FF2B5EF4-FFF2-40B4-BE49-F238E27FC236}">
-                <a16:creationId xmlns:a16="http://schemas.microsoft.com/office/drawing/2014/main" id="{5AB61352-984E-4C0D-8C07-174C542927B4}"/>
+                <a16:creationId xmlns:a16="http://schemas.microsoft.com/office/drawing/2014/main" id="{67298019-B1E6-4FB6-97B9-CDBAE1237898}"/>
               </a:ext>
             </a:extLst>
           </p:cNvPr>
@@ -14988,7 +15138,7 @@
           <p:cNvPr id="11" name="">
             <a:extLst xmlns:a="http://schemas.openxmlformats.org/drawingml/2006/main">
               <a:ext uri="{FF2B5EF4-FFF2-40B4-BE49-F238E27FC236}">
-                <a16:creationId xmlns:a16="http://schemas.microsoft.com/office/drawing/2014/main" id="{0FC2CDF1-6A64-424E-AEBA-530E76610A43}"/>
+                <a16:creationId xmlns:a16="http://schemas.microsoft.com/office/drawing/2014/main" id="{BC62CB9C-2629-41CE-803D-9C43C2FD16E1}"/>
               </a:ext>
             </a:extLst>
           </p:cNvPr>
@@ -15109,7 +15259,7 @@
           <p:cNvPr id="12" name="">
             <a:extLst xmlns:a="http://schemas.openxmlformats.org/drawingml/2006/main">
               <a:ext uri="{FF2B5EF4-FFF2-40B4-BE49-F238E27FC236}">
-                <a16:creationId xmlns:a16="http://schemas.microsoft.com/office/drawing/2014/main" id="{DCE56571-9550-4EE2-A763-4A41198B5CDC}"/>
+                <a16:creationId xmlns:a16="http://schemas.microsoft.com/office/drawing/2014/main" id="{8ECB28D9-D3D8-4184-BE39-360315613998}"/>
               </a:ext>
             </a:extLst>
           </p:cNvPr>
@@ -15228,7 +15378,7 @@
     </p:spTree>
     <p:extLst>
       <p:ext uri="{BB962C8B-B14F-4D97-AF65-F5344CB8AC3E}">
-        <p14:creationId xmlns:p14="http://schemas.microsoft.com/office/powerpoint/2010/main" val="1662548051"/>
+        <p14:creationId xmlns:p14="http://schemas.microsoft.com/office/powerpoint/2010/main" val="1776052357"/>
       </p:ext>
     </p:extLst>
   </p:cSld>
@@ -15259,7 +15409,7 @@
           <p:cNvPr id="14" name="">
             <a:extLst xmlns:a="http://schemas.openxmlformats.org/drawingml/2006/main">
               <a:ext uri="{FF2B5EF4-FFF2-40B4-BE49-F238E27FC236}">
-                <a16:creationId xmlns:a16="http://schemas.microsoft.com/office/drawing/2014/main" id="{0BA80F2E-0EE5-48B3-9979-22C41DEF0E43}"/>
+                <a16:creationId xmlns:a16="http://schemas.microsoft.com/office/drawing/2014/main" id="{7F620FB4-4910-47B0-AD9A-5BE9F1041537}"/>
               </a:ext>
             </a:extLst>
           </p:cNvPr>
@@ -15380,7 +15530,7 @@
           <p:cNvPr id="2" name="">
             <a:extLst xmlns:a="http://schemas.openxmlformats.org/drawingml/2006/main">
               <a:ext uri="{FF2B5EF4-FFF2-40B4-BE49-F238E27FC236}">
-                <a16:creationId xmlns:a16="http://schemas.microsoft.com/office/drawing/2014/main" id="{835F10B4-611F-4464-A124-D8A7534B4876}"/>
+                <a16:creationId xmlns:a16="http://schemas.microsoft.com/office/drawing/2014/main" id="{36359EF0-A8C2-4044-A23F-D45521CB16BC}"/>
               </a:ext>
             </a:extLst>
           </p:cNvPr>
@@ -15501,7 +15651,7 @@
           <p:cNvPr id="3" name="">
             <a:extLst xmlns:a="http://schemas.openxmlformats.org/drawingml/2006/main">
               <a:ext uri="{FF2B5EF4-FFF2-40B4-BE49-F238E27FC236}">
-                <a16:creationId xmlns:a16="http://schemas.microsoft.com/office/drawing/2014/main" id="{07028019-726A-476D-880B-6F3DC13733A4}"/>
+                <a16:creationId xmlns:a16="http://schemas.microsoft.com/office/drawing/2014/main" id="{822C9775-4B5B-44F0-89C0-8C674EA97EB0}"/>
               </a:ext>
             </a:extLst>
           </p:cNvPr>
@@ -15622,7 +15772,7 @@
           <p:cNvPr id="4" name="">
             <a:extLst xmlns:a="http://schemas.openxmlformats.org/drawingml/2006/main">
               <a:ext uri="{FF2B5EF4-FFF2-40B4-BE49-F238E27FC236}">
-                <a16:creationId xmlns:a16="http://schemas.microsoft.com/office/drawing/2014/main" id="{FF8223F1-49B4-4673-B21E-64057AC23033}"/>
+                <a16:creationId xmlns:a16="http://schemas.microsoft.com/office/drawing/2014/main" id="{81E4B7F6-D274-4B4A-ACE6-22BB4AE4396B}"/>
               </a:ext>
             </a:extLst>
           </p:cNvPr>
@@ -15743,7 +15893,7 @@
           <p:cNvPr id="5" name="">
             <a:extLst xmlns:a="http://schemas.openxmlformats.org/drawingml/2006/main">
               <a:ext uri="{FF2B5EF4-FFF2-40B4-BE49-F238E27FC236}">
-                <a16:creationId xmlns:a16="http://schemas.microsoft.com/office/drawing/2014/main" id="{B7F7C284-94AF-4FB3-9DC1-FE7B5C4685FB}"/>
+                <a16:creationId xmlns:a16="http://schemas.microsoft.com/office/drawing/2014/main" id="{EE356BD5-6DEE-448D-A798-6749DAD448E1}"/>
               </a:ext>
             </a:extLst>
           </p:cNvPr>
@@ -15864,7 +16014,7 @@
           <p:cNvPr id="6" name="">
             <a:extLst xmlns:a="http://schemas.openxmlformats.org/drawingml/2006/main">
               <a:ext uri="{FF2B5EF4-FFF2-40B4-BE49-F238E27FC236}">
-                <a16:creationId xmlns:a16="http://schemas.microsoft.com/office/drawing/2014/main" id="{DD0B0EBB-C1B3-40E5-9001-6F05F2EC7A2A}"/>
+                <a16:creationId xmlns:a16="http://schemas.microsoft.com/office/drawing/2014/main" id="{1ED373F3-70B9-4E22-978A-01B451DBB22E}"/>
               </a:ext>
             </a:extLst>
           </p:cNvPr>
@@ -15985,7 +16135,7 @@
           <p:cNvPr id="7" name="">
             <a:extLst xmlns:a="http://schemas.openxmlformats.org/drawingml/2006/main">
               <a:ext uri="{FF2B5EF4-FFF2-40B4-BE49-F238E27FC236}">
-                <a16:creationId xmlns:a16="http://schemas.microsoft.com/office/drawing/2014/main" id="{AD557B96-C9DC-4908-AA66-04CEC3A16E2E}"/>
+                <a16:creationId xmlns:a16="http://schemas.microsoft.com/office/drawing/2014/main" id="{052E223F-A645-4E65-9617-54A182F0D3D0}"/>
               </a:ext>
             </a:extLst>
           </p:cNvPr>
@@ -16106,7 +16256,7 @@
           <p:cNvPr id="8" name="">
             <a:extLst xmlns:a="http://schemas.openxmlformats.org/drawingml/2006/main">
               <a:ext uri="{FF2B5EF4-FFF2-40B4-BE49-F238E27FC236}">
-                <a16:creationId xmlns:a16="http://schemas.microsoft.com/office/drawing/2014/main" id="{EB5890F4-6D4E-4793-B5F2-25270F4C705B}"/>
+                <a16:creationId xmlns:a16="http://schemas.microsoft.com/office/drawing/2014/main" id="{33495B9F-1C03-400E-AD83-E62C4D5E0D9E}"/>
               </a:ext>
             </a:extLst>
           </p:cNvPr>
@@ -16227,7 +16377,7 @@
           <p:cNvPr id="9" name="">
             <a:extLst xmlns:a="http://schemas.openxmlformats.org/drawingml/2006/main">
               <a:ext uri="{FF2B5EF4-FFF2-40B4-BE49-F238E27FC236}">
-                <a16:creationId xmlns:a16="http://schemas.microsoft.com/office/drawing/2014/main" id="{6363C35B-F0A7-4C9D-86D7-1EA41D1901A2}"/>
+                <a16:creationId xmlns:a16="http://schemas.microsoft.com/office/drawing/2014/main" id="{73E1FBE5-1208-4108-B939-21C8466D8439}"/>
               </a:ext>
             </a:extLst>
           </p:cNvPr>
@@ -16237,7 +16387,7 @@
           <p:nvPr/>
         </p:nvPicPr>
         <p:blipFill>
-          <a:blip xmlns:r="http://schemas.openxmlformats.org/officeDocument/2006/relationships" xmlns:a="http://schemas.openxmlformats.org/drawingml/2006/main" r:embed="R8ca94d263ac445c7"/>
+          <a:blip xmlns:r="http://schemas.openxmlformats.org/officeDocument/2006/relationships" xmlns:a="http://schemas.openxmlformats.org/drawingml/2006/main" r:embed="R1171c8429e2c4377"/>
           <a:stretch xmlns:a="http://schemas.openxmlformats.org/drawingml/2006/main"/>
         </p:blipFill>
         <p:spPr>
@@ -16255,7 +16405,7 @@
           <p:cNvPr id="10" name="">
             <a:extLst xmlns:a="http://schemas.openxmlformats.org/drawingml/2006/main">
               <a:ext uri="{FF2B5EF4-FFF2-40B4-BE49-F238E27FC236}">
-                <a16:creationId xmlns:a16="http://schemas.microsoft.com/office/drawing/2014/main" id="{C086B286-CDC1-4DB2-BEE3-F85B89ABA56B}"/>
+                <a16:creationId xmlns:a16="http://schemas.microsoft.com/office/drawing/2014/main" id="{3A1A916F-7BC4-4109-9C04-60BBFF84F054}"/>
               </a:ext>
             </a:extLst>
           </p:cNvPr>
@@ -16376,7 +16526,7 @@
           <p:cNvPr id="11" name="">
             <a:extLst xmlns:a="http://schemas.openxmlformats.org/drawingml/2006/main">
               <a:ext uri="{FF2B5EF4-FFF2-40B4-BE49-F238E27FC236}">
-                <a16:creationId xmlns:a16="http://schemas.microsoft.com/office/drawing/2014/main" id="{0AAE006C-7ADA-44D5-93FD-464BDD311F4F}"/>
+                <a16:creationId xmlns:a16="http://schemas.microsoft.com/office/drawing/2014/main" id="{ECA8DEC1-9796-4BD5-A7C2-A3BE0950980C}"/>
               </a:ext>
             </a:extLst>
           </p:cNvPr>
@@ -16407,7 +16557,7 @@
           <p:cNvPr id="12" name="">
             <a:extLst xmlns:a="http://schemas.openxmlformats.org/drawingml/2006/main">
               <a:ext uri="{FF2B5EF4-FFF2-40B4-BE49-F238E27FC236}">
-                <a16:creationId xmlns:a16="http://schemas.microsoft.com/office/drawing/2014/main" id="{08C38A8D-D412-4354-AC01-47AB17371792}"/>
+                <a16:creationId xmlns:a16="http://schemas.microsoft.com/office/drawing/2014/main" id="{20266E65-62B6-4EF4-A530-B40B2F2DB84F}"/>
               </a:ext>
             </a:extLst>
           </p:cNvPr>
@@ -16528,7 +16678,7 @@
           <p:cNvPr id="13" name="">
             <a:extLst xmlns:a="http://schemas.openxmlformats.org/drawingml/2006/main">
               <a:ext uri="{FF2B5EF4-FFF2-40B4-BE49-F238E27FC236}">
-                <a16:creationId xmlns:a16="http://schemas.microsoft.com/office/drawing/2014/main" id="{9239869A-DE15-4311-8668-548182D6655D}"/>
+                <a16:creationId xmlns:a16="http://schemas.microsoft.com/office/drawing/2014/main" id="{C485FC09-9DE9-48D0-9B08-18302F027014}"/>
               </a:ext>
             </a:extLst>
           </p:cNvPr>
@@ -16647,7 +16797,7 @@
     </p:spTree>
     <p:extLst>
       <p:ext uri="{BB962C8B-B14F-4D97-AF65-F5344CB8AC3E}">
-        <p14:creationId xmlns:p14="http://schemas.microsoft.com/office/powerpoint/2010/main" val="1655143606"/>
+        <p14:creationId xmlns:p14="http://schemas.microsoft.com/office/powerpoint/2010/main" val="1773960882"/>
       </p:ext>
     </p:extLst>
   </p:cSld>
@@ -16678,7 +16828,7 @@
           <p:cNvPr id="10" name="">
             <a:extLst xmlns:a="http://schemas.openxmlformats.org/drawingml/2006/main">
               <a:ext uri="{FF2B5EF4-FFF2-40B4-BE49-F238E27FC236}">
-                <a16:creationId xmlns:a16="http://schemas.microsoft.com/office/drawing/2014/main" id="{A0E23618-6D77-4B8D-8E51-023857AC7E77}"/>
+                <a16:creationId xmlns:a16="http://schemas.microsoft.com/office/drawing/2014/main" id="{707D3EDF-6B8F-4FBB-B355-6E1BDC1F5DC5}"/>
               </a:ext>
             </a:extLst>
           </p:cNvPr>
@@ -16799,7 +16949,7 @@
           <p:cNvPr id="2" name="">
             <a:extLst xmlns:a="http://schemas.openxmlformats.org/drawingml/2006/main">
               <a:ext uri="{FF2B5EF4-FFF2-40B4-BE49-F238E27FC236}">
-                <a16:creationId xmlns:a16="http://schemas.microsoft.com/office/drawing/2014/main" id="{FF300CDB-D2B2-40F1-BE31-FBB86D2A159F}"/>
+                <a16:creationId xmlns:a16="http://schemas.microsoft.com/office/drawing/2014/main" id="{63C8982B-0909-4FC2-BD25-A7C87FF49AD0}"/>
               </a:ext>
             </a:extLst>
           </p:cNvPr>
@@ -16954,7 +17104,7 @@
           <p:cNvPr id="3" name="">
             <a:extLst xmlns:a="http://schemas.openxmlformats.org/drawingml/2006/main">
               <a:ext uri="{FF2B5EF4-FFF2-40B4-BE49-F238E27FC236}">
-                <a16:creationId xmlns:a16="http://schemas.microsoft.com/office/drawing/2014/main" id="{16F97AA4-F4E2-40AD-8BEF-3E310A9899B8}"/>
+                <a16:creationId xmlns:a16="http://schemas.microsoft.com/office/drawing/2014/main" id="{AD9212BD-98DE-40FA-BE53-FD73A31B65A6}"/>
               </a:ext>
             </a:extLst>
           </p:cNvPr>
@@ -17075,7 +17225,7 @@
           <p:cNvPr id="4" name="">
             <a:extLst xmlns:a="http://schemas.openxmlformats.org/drawingml/2006/main">
               <a:ext uri="{FF2B5EF4-FFF2-40B4-BE49-F238E27FC236}">
-                <a16:creationId xmlns:a16="http://schemas.microsoft.com/office/drawing/2014/main" id="{B42D9B1F-1DE1-4EC3-9719-570C43961864}"/>
+                <a16:creationId xmlns:a16="http://schemas.microsoft.com/office/drawing/2014/main" id="{359B29C0-3A02-4720-BCC7-F8B84C4BCE7F}"/>
               </a:ext>
             </a:extLst>
           </p:cNvPr>
@@ -17196,7 +17346,7 @@
           <p:cNvPr id="5" name="">
             <a:extLst xmlns:a="http://schemas.openxmlformats.org/drawingml/2006/main">
               <a:ext uri="{FF2B5EF4-FFF2-40B4-BE49-F238E27FC236}">
-                <a16:creationId xmlns:a16="http://schemas.microsoft.com/office/drawing/2014/main" id="{0CD33764-D90F-4C28-8E49-773D7D7BC06F}"/>
+                <a16:creationId xmlns:a16="http://schemas.microsoft.com/office/drawing/2014/main" id="{BA773855-B8E9-4116-8318-EB4B26EBA843}"/>
               </a:ext>
             </a:extLst>
           </p:cNvPr>
@@ -17206,7 +17356,7 @@
           <p:nvPr/>
         </p:nvPicPr>
         <p:blipFill>
-          <a:blip xmlns:r="http://schemas.openxmlformats.org/officeDocument/2006/relationships" xmlns:a="http://schemas.openxmlformats.org/drawingml/2006/main" r:embed="R1522a990db9d4742"/>
+          <a:blip xmlns:r="http://schemas.openxmlformats.org/officeDocument/2006/relationships" xmlns:a="http://schemas.openxmlformats.org/drawingml/2006/main" r:embed="R7951e6422c2141d0"/>
           <a:stretch xmlns:a="http://schemas.openxmlformats.org/drawingml/2006/main"/>
         </p:blipFill>
         <p:spPr>
@@ -17224,7 +17374,7 @@
           <p:cNvPr id="6" name="">
             <a:extLst xmlns:a="http://schemas.openxmlformats.org/drawingml/2006/main">
               <a:ext uri="{FF2B5EF4-FFF2-40B4-BE49-F238E27FC236}">
-                <a16:creationId xmlns:a16="http://schemas.microsoft.com/office/drawing/2014/main" id="{2024779E-858C-4EA4-951B-5F6F771FB1BF}"/>
+                <a16:creationId xmlns:a16="http://schemas.microsoft.com/office/drawing/2014/main" id="{0DF819FF-8012-4C0B-85DA-14993F827D31}"/>
               </a:ext>
             </a:extLst>
           </p:cNvPr>
@@ -17345,7 +17495,7 @@
           <p:cNvPr id="7" name="">
             <a:extLst xmlns:a="http://schemas.openxmlformats.org/drawingml/2006/main">
               <a:ext uri="{FF2B5EF4-FFF2-40B4-BE49-F238E27FC236}">
-                <a16:creationId xmlns:a16="http://schemas.microsoft.com/office/drawing/2014/main" id="{B555878D-141C-45A6-B7F0-C54778231A5A}"/>
+                <a16:creationId xmlns:a16="http://schemas.microsoft.com/office/drawing/2014/main" id="{0B0A1817-444E-43CC-9E5E-84D41BAA35EA}"/>
               </a:ext>
             </a:extLst>
           </p:cNvPr>
@@ -17376,7 +17526,7 @@
           <p:cNvPr id="8" name="">
             <a:extLst xmlns:a="http://schemas.openxmlformats.org/drawingml/2006/main">
               <a:ext uri="{FF2B5EF4-FFF2-40B4-BE49-F238E27FC236}">
-                <a16:creationId xmlns:a16="http://schemas.microsoft.com/office/drawing/2014/main" id="{9AB74607-8FC7-482C-9FA4-53221E0E2708}"/>
+                <a16:creationId xmlns:a16="http://schemas.microsoft.com/office/drawing/2014/main" id="{430A3D4B-0F29-4260-997F-D852239381CE}"/>
               </a:ext>
             </a:extLst>
           </p:cNvPr>
@@ -17497,7 +17647,7 @@
           <p:cNvPr id="9" name="">
             <a:extLst xmlns:a="http://schemas.openxmlformats.org/drawingml/2006/main">
               <a:ext uri="{FF2B5EF4-FFF2-40B4-BE49-F238E27FC236}">
-                <a16:creationId xmlns:a16="http://schemas.microsoft.com/office/drawing/2014/main" id="{08153FB2-A455-49E1-8604-AAB7C3621446}"/>
+                <a16:creationId xmlns:a16="http://schemas.microsoft.com/office/drawing/2014/main" id="{3F94B111-F247-4297-BF91-A5EF175F5871}"/>
               </a:ext>
             </a:extLst>
           </p:cNvPr>
@@ -17616,7 +17766,7 @@
     </p:spTree>
     <p:extLst>
       <p:ext uri="{BB962C8B-B14F-4D97-AF65-F5344CB8AC3E}">
-        <p14:creationId xmlns:p14="http://schemas.microsoft.com/office/powerpoint/2010/main" val="1381522087"/>
+        <p14:creationId xmlns:p14="http://schemas.microsoft.com/office/powerpoint/2010/main" val="1365562017"/>
       </p:ext>
     </p:extLst>
   </p:cSld>

</xml_diff>